<commit_message>
Fix applications differentiation exam answer
</commit_message>
<xml_diff>
--- a/generated-slides/year-12-advanced/further-integral-calculus/trapezoidal-rule.pptx
+++ b/generated-slides/year-12-advanced/further-integral-calculus/trapezoidal-rule.pptx
@@ -514,6 +514,7 @@
               <a:rPr lang="en-US" dirty="0"/>
               <a:t>Welcome. Today we're looking at The Trapezoidal Rule.
 Course: Year 12 Mathematics Advanced – Further Integral Calculus
+Learning Intention: Use the trapezoidal rule to approximate definite integrals and judge when the approximation is likely to overestimate or underestimate.
 Overview: Approximate definite integrals from functions or tables using one or more trapezoids, and interpret the effect of concavity.</a:t>
             </a:r>
             <a:endParaRPr lang="en-US" dirty="0"/>
@@ -1856,7 +1857,7 @@
         <p:spPr>
           <a:xfrm>
             <a:off x="0" y="0"/>
-            <a:ext cx="9144000" cy="2983230"/>
+            <a:ext cx="12192000" cy="6858000"/>
           </a:xfrm>
           <a:prstGeom prst="rect">
             <a:avLst/>
@@ -1875,8 +1876,8 @@
         </p:nvSpPr>
         <p:spPr>
           <a:xfrm>
-            <a:off x="384048" y="457200"/>
-            <a:ext cx="8375904" cy="1554480"/>
+            <a:off x="502920" y="914400"/>
+            <a:ext cx="11186160" cy="1828800"/>
           </a:xfrm>
           <a:prstGeom prst="rect">
             <a:avLst/>
@@ -1892,14 +1893,14 @@
               <a:buNone/>
             </a:pPr>
             <a:r>
-              <a:rPr lang="en-US" sz="3400" b="1" dirty="0">
+              <a:rPr lang="en-US" sz="4200" b="1" dirty="0">
                 <a:solidFill>
                   <a:srgbClr val="FFFFFF"/>
                 </a:solidFill>
               </a:rPr>
               <a:t>The Trapezoidal Rule</a:t>
             </a:r>
-            <a:endParaRPr lang="en-US" sz="3400" dirty="0"/>
+            <a:endParaRPr lang="en-US" sz="4200" dirty="0"/>
           </a:p>
         </p:txBody>
       </p:sp>
@@ -1911,8 +1912,8 @@
         </p:nvSpPr>
         <p:spPr>
           <a:xfrm>
-            <a:off x="384048" y="2011680"/>
-            <a:ext cx="8375904" cy="411480"/>
+            <a:off x="502920" y="2697480"/>
+            <a:ext cx="11186160" cy="438912"/>
           </a:xfrm>
           <a:prstGeom prst="rect">
             <a:avLst/>
@@ -1928,12 +1929,106 @@
               <a:buNone/>
             </a:pPr>
             <a:r>
+              <a:rPr lang="en-US" sz="1600" dirty="0">
+                <a:solidFill>
+                  <a:srgbClr val="BDD9F2"/>
+                </a:solidFill>
+              </a:rPr>
+              <a:t>Year 12 Mathematics Advanced  ·  Further Integral Calculus</a:t>
+            </a:r>
+            <a:endParaRPr lang="en-US" sz="1600" dirty="0"/>
+          </a:p>
+        </p:txBody>
+      </p:sp>
+      <p:sp>
+        <p:nvSpPr>
+          <p:cNvPr id="5" name="Shape 3"/>
+          <p:cNvSpPr/>
+          <p:nvPr/>
+        </p:nvSpPr>
+        <p:spPr>
+          <a:xfrm>
+            <a:off x="2011680" y="3429000"/>
+            <a:ext cx="8168640" cy="1874520"/>
+          </a:xfrm>
+          <a:prstGeom prst="roundRect">
+            <a:avLst>
+              <a:gd name="adj" fmla="val 4878"/>
+            </a:avLst>
+          </a:prstGeom>
+          <a:solidFill>
+            <a:srgbClr val="EBF4FF"/>
+          </a:solidFill>
+          <a:ln/>
+        </p:spPr>
+      </p:sp>
+      <p:sp>
+        <p:nvSpPr>
+          <p:cNvPr id="6" name="Text 4"/>
+          <p:cNvSpPr/>
+          <p:nvPr/>
+        </p:nvSpPr>
+        <p:spPr>
+          <a:xfrm>
+            <a:off x="2304288" y="3593592"/>
+            <a:ext cx="7583424" cy="310896"/>
+          </a:xfrm>
+          <a:prstGeom prst="rect">
+            <a:avLst/>
+          </a:prstGeom>
+          <a:noFill/>
+          <a:ln/>
+        </p:spPr>
+        <p:txBody>
+          <a:bodyPr wrap="square" rtlCol="0" anchor="ctr"/>
+          <a:lstStyle/>
+          <a:p>
+            <a:pPr indent="0" marL="0">
+              <a:buNone/>
+            </a:pPr>
+            <a:r>
+              <a:rPr lang="en-US" sz="1200" b="1" dirty="0">
+                <a:solidFill>
+                  <a:srgbClr val="1B3A6B"/>
+                </a:solidFill>
+              </a:rPr>
+              <a:t>Learning Intention</a:t>
+            </a:r>
+            <a:endParaRPr lang="en-US" sz="1200" dirty="0"/>
+          </a:p>
+        </p:txBody>
+      </p:sp>
+      <p:sp>
+        <p:nvSpPr>
+          <p:cNvPr id="7" name="Text 5"/>
+          <p:cNvSpPr/>
+          <p:nvPr/>
+        </p:nvSpPr>
+        <p:spPr>
+          <a:xfrm>
+            <a:off x="2304288" y="3904488"/>
+            <a:ext cx="7583424" cy="1252728"/>
+          </a:xfrm>
+          <a:prstGeom prst="rect">
+            <a:avLst/>
+          </a:prstGeom>
+          <a:noFill/>
+          <a:ln/>
+        </p:spPr>
+        <p:txBody>
+          <a:bodyPr wrap="square" rtlCol="0" anchor="t"/>
+          <a:lstStyle/>
+          <a:p>
+            <a:pPr indent="0" marL="0">
+              <a:buNone/>
+            </a:pPr>
+            <a:r>
               <a:rPr lang="en-US" sz="1300" dirty="0">
                 <a:solidFill>
-                  <a:srgbClr val="BDD9F2"/>
-                </a:solidFill>
-              </a:rPr>
-              <a:t>Year 12 Mathematics Advanced  ·  Further Integral Calculus</a:t>
+                  <a:srgbClr val="1A1A1A"/>
+                </a:solidFill>
+              </a:rPr>
+              <a:t>Use the trapezoidal rule to approximate definite integrals and judge when the approximation is likely to overestimate or underestimate.</a:t>
             </a:r>
             <a:endParaRPr lang="en-US" sz="1300" dirty="0"/>
           </a:p>
@@ -1941,14 +2036,14 @@
       </p:sp>
       <p:sp>
         <p:nvSpPr>
-          <p:cNvPr id="5" name="Text 3"/>
-          <p:cNvSpPr/>
-          <p:nvPr/>
-        </p:nvSpPr>
-        <p:spPr>
-          <a:xfrm>
-            <a:off x="1371600" y="3154680"/>
-            <a:ext cx="6400800" cy="868680"/>
+          <p:cNvPr id="8" name="Text 6"/>
+          <p:cNvSpPr/>
+          <p:nvPr/>
+        </p:nvSpPr>
+        <p:spPr>
+          <a:xfrm>
+            <a:off x="502920" y="6400800"/>
+            <a:ext cx="11186160" cy="329184"/>
           </a:xfrm>
           <a:prstGeom prst="rect">
             <a:avLst/>
@@ -1964,14 +2059,14 @@
               <a:buNone/>
             </a:pPr>
             <a:r>
-              <a:rPr lang="en-US" sz="1100" i="1" dirty="0">
-                <a:solidFill>
-                  <a:srgbClr val="555555"/>
-                </a:solidFill>
-              </a:rPr>
-              <a:t>Approximate definite integrals from functions or tables using one or more trapezoids, and interpret the effect of concavity.</a:t>
-            </a:r>
-            <a:endParaRPr lang="en-US" sz="1100" dirty="0"/>
+              <a:rPr lang="en-US" sz="1200" dirty="0">
+                <a:solidFill>
+                  <a:srgbClr val="A8C8E8"/>
+                </a:solidFill>
+              </a:rPr>
+              <a:t>HSC Maths Coach</a:t>
+            </a:r>
+            <a:endParaRPr lang="en-US" sz="1200" dirty="0"/>
           </a:p>
         </p:txBody>
       </p:sp>
@@ -2009,7 +2104,7 @@
         <p:spPr>
           <a:xfrm>
             <a:off x="0" y="0"/>
-            <a:ext cx="9144000" cy="658368"/>
+            <a:ext cx="12192000" cy="804672"/>
           </a:xfrm>
           <a:prstGeom prst="rect">
             <a:avLst/>
@@ -2028,31 +2123,31 @@
         </p:nvSpPr>
         <p:spPr>
           <a:xfrm>
-            <a:off x="384048" y="0"/>
-            <a:ext cx="8375904" cy="658368"/>
-          </a:xfrm>
-          <a:prstGeom prst="rect">
-            <a:avLst/>
-          </a:prstGeom>
-          <a:noFill/>
-          <a:ln/>
-        </p:spPr>
-        <p:txBody>
-          <a:bodyPr wrap="square" rtlCol="0" anchor="ctr"/>
-          <a:lstStyle/>
-          <a:p>
-            <a:pPr indent="0" marL="0">
-              <a:buNone/>
-            </a:pPr>
-            <a:r>
-              <a:rPr lang="en-US" sz="1800" b="1" dirty="0">
+            <a:off x="502920" y="0"/>
+            <a:ext cx="11186160" cy="804672"/>
+          </a:xfrm>
+          <a:prstGeom prst="rect">
+            <a:avLst/>
+          </a:prstGeom>
+          <a:noFill/>
+          <a:ln/>
+        </p:spPr>
+        <p:txBody>
+          <a:bodyPr wrap="square" rtlCol="0" anchor="ctr"/>
+          <a:lstStyle/>
+          <a:p>
+            <a:pPr indent="0" marL="0">
+              <a:buNone/>
+            </a:pPr>
+            <a:r>
+              <a:rPr lang="en-US" sz="2200" b="1" dirty="0">
                 <a:solidFill>
                   <a:srgbClr val="FFFFFF"/>
                 </a:solidFill>
               </a:rPr>
               <a:t>Your Turn – Guided Practice</a:t>
             </a:r>
-            <a:endParaRPr lang="en-US" sz="1800" dirty="0"/>
+            <a:endParaRPr lang="en-US" sz="2200" dirty="0"/>
           </a:p>
         </p:txBody>
       </p:sp>
@@ -2064,31 +2159,31 @@
         </p:nvSpPr>
         <p:spPr>
           <a:xfrm>
-            <a:off x="384048" y="841248"/>
-            <a:ext cx="8375904" cy="274320"/>
-          </a:xfrm>
-          <a:prstGeom prst="rect">
-            <a:avLst/>
-          </a:prstGeom>
-          <a:noFill/>
-          <a:ln/>
-        </p:spPr>
-        <p:txBody>
-          <a:bodyPr wrap="square" rtlCol="0" anchor="ctr"/>
-          <a:lstStyle/>
-          <a:p>
-            <a:pPr indent="0" marL="0">
-              <a:buNone/>
-            </a:pPr>
-            <a:r>
-              <a:rPr lang="en-US" sz="1050" i="1" dirty="0">
+            <a:off x="502920" y="1005840"/>
+            <a:ext cx="11186160" cy="329184"/>
+          </a:xfrm>
+          <a:prstGeom prst="rect">
+            <a:avLst/>
+          </a:prstGeom>
+          <a:noFill/>
+          <a:ln/>
+        </p:spPr>
+        <p:txBody>
+          <a:bodyPr wrap="square" rtlCol="0" anchor="ctr"/>
+          <a:lstStyle/>
+          <a:p>
+            <a:pPr indent="0" marL="0">
+              <a:buNone/>
+            </a:pPr>
+            <a:r>
+              <a:rPr lang="en-US" sz="1200" dirty="0">
                 <a:solidFill>
                   <a:srgbClr val="555555"/>
                 </a:solidFill>
               </a:rPr>
               <a:t>Pause the video and try this question. Write your working below.</a:t>
             </a:r>
-            <a:endParaRPr lang="en-US" sz="1050" dirty="0"/>
+            <a:endParaRPr lang="en-US" sz="1200" dirty="0"/>
           </a:p>
         </p:txBody>
       </p:sp>
@@ -2100,11 +2195,13 @@
         </p:nvSpPr>
         <p:spPr>
           <a:xfrm>
-            <a:off x="384048" y="1170432"/>
-            <a:ext cx="8375904" cy="566928"/>
-          </a:xfrm>
-          <a:prstGeom prst="rect">
-            <a:avLst/>
+            <a:off x="502920" y="1426464"/>
+            <a:ext cx="11186160" cy="713232"/>
+          </a:xfrm>
+          <a:prstGeom prst="roundRect">
+            <a:avLst>
+              <a:gd name="adj" fmla="val 12821"/>
+            </a:avLst>
           </a:prstGeom>
           <a:solidFill>
             <a:srgbClr val="EBF4FF"/>
@@ -2120,31 +2217,31 @@
         </p:nvSpPr>
         <p:spPr>
           <a:xfrm>
-            <a:off x="512064" y="1170432"/>
-            <a:ext cx="4187952" cy="566928"/>
-          </a:xfrm>
-          <a:prstGeom prst="rect">
-            <a:avLst/>
-          </a:prstGeom>
-          <a:noFill/>
-          <a:ln/>
-        </p:spPr>
-        <p:txBody>
-          <a:bodyPr wrap="square" rtlCol="0" anchor="ctr"/>
-          <a:lstStyle/>
-          <a:p>
-            <a:pPr indent="0" marL="0">
-              <a:buNone/>
-            </a:pPr>
-            <a:r>
-              <a:rPr lang="en-US" sz="1200" b="1" dirty="0">
+            <a:off x="667512" y="1426464"/>
+            <a:ext cx="5593080" cy="713232"/>
+          </a:xfrm>
+          <a:prstGeom prst="rect">
+            <a:avLst/>
+          </a:prstGeom>
+          <a:noFill/>
+          <a:ln/>
+        </p:spPr>
+        <p:txBody>
+          <a:bodyPr wrap="square" rtlCol="0" anchor="ctr"/>
+          <a:lstStyle/>
+          <a:p>
+            <a:pPr indent="0" marL="0">
+              <a:buNone/>
+            </a:pPr>
+            <a:r>
+              <a:rPr lang="en-US" sz="1300" b="1" dirty="0">
                 <a:solidFill>
                   <a:srgbClr val="1A1A1A"/>
                 </a:solidFill>
               </a:rPr>
               <a:t>Use one trapezoid to approximate the integral.</a:t>
             </a:r>
-            <a:endParaRPr lang="en-US" sz="1200" dirty="0"/>
+            <a:endParaRPr lang="en-US" sz="1300" dirty="0"/>
           </a:p>
         </p:txBody>
       </p:sp>
@@ -2156,24 +2253,24 @@
         </p:nvSpPr>
         <p:spPr>
           <a:xfrm>
-            <a:off x="4739518" y="1207008"/>
-            <a:ext cx="3685398" cy="493776"/>
-          </a:xfrm>
-          <a:prstGeom prst="rect">
-            <a:avLst/>
-          </a:prstGeom>
-          <a:noFill/>
-          <a:ln/>
-        </p:spPr>
-        <p:txBody>
-          <a:bodyPr wrap="square" rtlCol="0" anchor="ctr"/>
-          <a:lstStyle/>
-          <a:p>
-            <a:pPr indent="0" marL="0">
-              <a:buNone/>
-            </a:pPr>
-            <a:r>
-              <a:rPr lang="en-US" sz="1200" dirty="0">
+            <a:off x="6319723" y="1463040"/>
+            <a:ext cx="4921910" cy="640080"/>
+          </a:xfrm>
+          <a:prstGeom prst="rect">
+            <a:avLst/>
+          </a:prstGeom>
+          <a:noFill/>
+          <a:ln/>
+        </p:spPr>
+        <p:txBody>
+          <a:bodyPr wrap="square" rtlCol="0" anchor="ctr"/>
+          <a:lstStyle/>
+          <a:p>
+            <a:pPr indent="0" marL="0">
+              <a:buNone/>
+            </a:pPr>
+            <a:r>
+              <a:rPr lang="en-US" sz="1300" dirty="0">
                 <a:solidFill>
                   <a:srgbClr val="1A1A1A"/>
                 </a:solidFill>
@@ -2181,9 +2278,9 @@
                 <a:ea typeface="Cambria Math" pitchFamily="34" charset="-122"/>
                 <a:cs typeface="Cambria Math" pitchFamily="34" charset="-120"/>
               </a:rPr>
-              <a:t>∫ x² dx</a:t>
-            </a:r>
-            <a:endParaRPr lang="en-US" sz="1200" dirty="0"/>
+              <a:t>∫ x² dx</a:t>
+            </a:r>
+            <a:endParaRPr lang="en-US" sz="1300" dirty="0"/>
           </a:p>
         </p:txBody>
       </p:sp>
@@ -2195,31 +2292,31 @@
         </p:nvSpPr>
         <p:spPr>
           <a:xfrm>
-            <a:off x="384048" y="1828800"/>
-            <a:ext cx="8375904" cy="310896"/>
-          </a:xfrm>
-          <a:prstGeom prst="rect">
-            <a:avLst/>
-          </a:prstGeom>
-          <a:noFill/>
-          <a:ln/>
-        </p:spPr>
-        <p:txBody>
-          <a:bodyPr wrap="square" rtlCol="0" anchor="ctr"/>
-          <a:lstStyle/>
-          <a:p>
-            <a:pPr indent="0" marL="0">
-              <a:buNone/>
-            </a:pPr>
-            <a:r>
-              <a:rPr lang="en-US" sz="1000" i="1" dirty="0">
+            <a:off x="502920" y="2249424"/>
+            <a:ext cx="11186160" cy="365760"/>
+          </a:xfrm>
+          <a:prstGeom prst="rect">
+            <a:avLst/>
+          </a:prstGeom>
+          <a:noFill/>
+          <a:ln/>
+        </p:spPr>
+        <p:txBody>
+          <a:bodyPr wrap="square" rtlCol="0" anchor="ctr"/>
+          <a:lstStyle/>
+          <a:p>
+            <a:pPr indent="0" marL="0">
+              <a:buNone/>
+            </a:pPr>
+            <a:r>
+              <a:rPr lang="en-US" sz="1100" dirty="0">
                 <a:solidFill>
                   <a:srgbClr val="555555"/>
                 </a:solidFill>
               </a:rPr>
               <a:t>Hint: Identify h and combine the endpoint and interior y-values carefully.</a:t>
             </a:r>
-            <a:endParaRPr lang="en-US" sz="1000" dirty="0"/>
+            <a:endParaRPr lang="en-US" sz="1100" dirty="0"/>
           </a:p>
         </p:txBody>
       </p:sp>
@@ -2231,31 +2328,31 @@
         </p:nvSpPr>
         <p:spPr>
           <a:xfrm>
-            <a:off x="384048" y="2231136"/>
-            <a:ext cx="1828800" cy="256032"/>
-          </a:xfrm>
-          <a:prstGeom prst="rect">
-            <a:avLst/>
-          </a:prstGeom>
-          <a:noFill/>
-          <a:ln/>
-        </p:spPr>
-        <p:txBody>
-          <a:bodyPr wrap="square" rtlCol="0" anchor="ctr"/>
-          <a:lstStyle/>
-          <a:p>
-            <a:pPr indent="0" marL="0">
-              <a:buNone/>
-            </a:pPr>
-            <a:r>
-              <a:rPr lang="en-US" sz="1000" b="1" dirty="0">
+            <a:off x="502920" y="2724912"/>
+            <a:ext cx="2286000" cy="292608"/>
+          </a:xfrm>
+          <a:prstGeom prst="rect">
+            <a:avLst/>
+          </a:prstGeom>
+          <a:noFill/>
+          <a:ln/>
+        </p:spPr>
+        <p:txBody>
+          <a:bodyPr wrap="square" rtlCol="0" anchor="ctr"/>
+          <a:lstStyle/>
+          <a:p>
+            <a:pPr indent="0" marL="0">
+              <a:buNone/>
+            </a:pPr>
+            <a:r>
+              <a:rPr lang="en-US" sz="1100" b="1" dirty="0">
                 <a:solidFill>
                   <a:srgbClr val="555555"/>
                 </a:solidFill>
               </a:rPr>
               <a:t>My working:</a:t>
             </a:r>
-            <a:endParaRPr lang="en-US" sz="1000" dirty="0"/>
+            <a:endParaRPr lang="en-US" sz="1100" dirty="0"/>
           </a:p>
         </p:txBody>
       </p:sp>
@@ -2267,8 +2364,8 @@
         </p:nvSpPr>
         <p:spPr>
           <a:xfrm>
-            <a:off x="384048" y="2505456"/>
-            <a:ext cx="8375904" cy="2436876"/>
+            <a:off x="502920" y="3054096"/>
+            <a:ext cx="11186160" cy="3511296"/>
           </a:xfrm>
           <a:prstGeom prst="rect">
             <a:avLst/>
@@ -2318,7 +2415,7 @@
         <p:spPr>
           <a:xfrm>
             <a:off x="0" y="0"/>
-            <a:ext cx="9144000" cy="658368"/>
+            <a:ext cx="12192000" cy="804672"/>
           </a:xfrm>
           <a:prstGeom prst="rect">
             <a:avLst/>
@@ -2337,31 +2434,31 @@
         </p:nvSpPr>
         <p:spPr>
           <a:xfrm>
-            <a:off x="384048" y="0"/>
-            <a:ext cx="8375904" cy="658368"/>
-          </a:xfrm>
-          <a:prstGeom prst="rect">
-            <a:avLst/>
-          </a:prstGeom>
-          <a:noFill/>
-          <a:ln/>
-        </p:spPr>
-        <p:txBody>
-          <a:bodyPr wrap="square" rtlCol="0" anchor="ctr"/>
-          <a:lstStyle/>
-          <a:p>
-            <a:pPr indent="0" marL="0">
-              <a:buNone/>
-            </a:pPr>
-            <a:r>
-              <a:rPr lang="en-US" sz="1800" b="1" dirty="0">
+            <a:off x="502920" y="0"/>
+            <a:ext cx="11186160" cy="804672"/>
+          </a:xfrm>
+          <a:prstGeom prst="rect">
+            <a:avLst/>
+          </a:prstGeom>
+          <a:noFill/>
+          <a:ln/>
+        </p:spPr>
+        <p:txBody>
+          <a:bodyPr wrap="square" rtlCol="0" anchor="ctr"/>
+          <a:lstStyle/>
+          <a:p>
+            <a:pPr indent="0" marL="0">
+              <a:buNone/>
+            </a:pPr>
+            <a:r>
+              <a:rPr lang="en-US" sz="2200" b="1" dirty="0">
                 <a:solidFill>
                   <a:srgbClr val="FFFFFF"/>
                 </a:solidFill>
               </a:rPr>
               <a:t>Summary</a:t>
             </a:r>
-            <a:endParaRPr lang="en-US" sz="1800" dirty="0"/>
+            <a:endParaRPr lang="en-US" sz="2200" dirty="0"/>
           </a:p>
         </p:txBody>
       </p:sp>
@@ -2373,31 +2470,31 @@
         </p:nvSpPr>
         <p:spPr>
           <a:xfrm>
-            <a:off x="384048" y="841248"/>
-            <a:ext cx="8375904" cy="274320"/>
-          </a:xfrm>
-          <a:prstGeom prst="rect">
-            <a:avLst/>
-          </a:prstGeom>
-          <a:noFill/>
-          <a:ln/>
-        </p:spPr>
-        <p:txBody>
-          <a:bodyPr wrap="square" rtlCol="0" anchor="ctr"/>
-          <a:lstStyle/>
-          <a:p>
-            <a:pPr indent="0" marL="0">
-              <a:buNone/>
-            </a:pPr>
-            <a:r>
-              <a:rPr lang="en-US" sz="1150" b="1" dirty="0">
+            <a:off x="502920" y="1005840"/>
+            <a:ext cx="11186160" cy="329184"/>
+          </a:xfrm>
+          <a:prstGeom prst="rect">
+            <a:avLst/>
+          </a:prstGeom>
+          <a:noFill/>
+          <a:ln/>
+        </p:spPr>
+        <p:txBody>
+          <a:bodyPr wrap="square" rtlCol="0" anchor="ctr"/>
+          <a:lstStyle/>
+          <a:p>
+            <a:pPr indent="0" marL="0">
+              <a:buNone/>
+            </a:pPr>
+            <a:r>
+              <a:rPr lang="en-US" sz="1300" b="1" dirty="0">
                 <a:solidFill>
                   <a:srgbClr val="1B3A6B"/>
                 </a:solidFill>
               </a:rPr>
               <a:t>Key ideas from this lesson:</a:t>
             </a:r>
-            <a:endParaRPr lang="en-US" sz="1150" dirty="0"/>
+            <a:endParaRPr lang="en-US" sz="1300" dirty="0"/>
           </a:p>
         </p:txBody>
       </p:sp>
@@ -2409,8 +2506,8 @@
         </p:nvSpPr>
         <p:spPr>
           <a:xfrm>
-            <a:off x="475488" y="1188720"/>
-            <a:ext cx="8193024" cy="3753612"/>
+            <a:off x="630936" y="1408176"/>
+            <a:ext cx="10930128" cy="5193792"/>
           </a:xfrm>
           <a:prstGeom prst="rect">
             <a:avLst/>
@@ -2424,128 +2521,128 @@
           <a:p>
             <a:pPr marL="342900" indent="-342900">
               <a:spcAft>
-                <a:spcPts val="400"/>
+                <a:spcPts val="500"/>
               </a:spcAft>
               <a:buSzPct val="100000"/>
               <a:buChar char="•"/>
             </a:pPr>
             <a:r>
-              <a:rPr lang="en-US" sz="1100" dirty="0">
+              <a:rPr lang="en-US" sz="1300" dirty="0">
                 <a:solidFill>
                   <a:srgbClr val="1A1A1A"/>
                 </a:solidFill>
               </a:rPr>
               <a:t>Divide [a, b] into n equal subintervals of width  h = (b−a)/n.</a:t>
             </a:r>
-            <a:endParaRPr lang="en-US" sz="1100" dirty="0"/>
+            <a:endParaRPr lang="en-US" sz="1300" dirty="0"/>
           </a:p>
           <a:p>
             <a:pPr marL="342900" indent="-342900">
               <a:spcAft>
-                <a:spcPts val="400"/>
+                <a:spcPts val="500"/>
               </a:spcAft>
               <a:buSzPct val="100000"/>
               <a:buChar char="•"/>
             </a:pPr>
             <a:r>
-              <a:rPr lang="en-US" sz="1100" dirty="0">
+              <a:rPr lang="en-US" sz="1300" dirty="0">
                 <a:solidFill>
                   <a:srgbClr val="1A1A1A"/>
                 </a:solidFill>
               </a:rPr>
               <a:t>Formula:  (h/2)[y₀ + 2y₁ + 2y₂ + ⋯ + 2yₙ₋₁ + yₙ]</a:t>
             </a:r>
-            <a:endParaRPr lang="en-US" sz="1100" dirty="0"/>
+            <a:endParaRPr lang="en-US" sz="1300" dirty="0"/>
           </a:p>
           <a:p>
             <a:pPr marL="342900" indent="-342900">
               <a:spcAft>
-                <a:spcPts val="400"/>
+                <a:spcPts val="500"/>
               </a:spcAft>
               <a:buSzPct val="100000"/>
               <a:buChar char="•"/>
             </a:pPr>
             <a:r>
-              <a:rPr lang="en-US" sz="1100" dirty="0">
+              <a:rPr lang="en-US" sz="1300" dirty="0">
                 <a:solidFill>
                   <a:srgbClr val="1A1A1A"/>
                 </a:solidFill>
               </a:rPr>
               <a:t>Endpoints y₀ and yₙ — coefficient 1.  Interior values — coefficient 2.</a:t>
             </a:r>
-            <a:endParaRPr lang="en-US" sz="1100" dirty="0"/>
+            <a:endParaRPr lang="en-US" sz="1300" dirty="0"/>
           </a:p>
           <a:p>
             <a:pPr marL="342900" indent="-342900">
               <a:spcAft>
-                <a:spcPts val="400"/>
+                <a:spcPts val="500"/>
               </a:spcAft>
               <a:buSzPct val="100000"/>
               <a:buChar char="•"/>
             </a:pPr>
             <a:r>
-              <a:rPr lang="en-US" sz="1100" dirty="0">
+              <a:rPr lang="en-US" sz="1300" dirty="0">
                 <a:solidFill>
                   <a:srgbClr val="1A1A1A"/>
                 </a:solidFill>
               </a:rPr>
               <a:t>From a table of values: read h from the x-spacing, then apply the formula.</a:t>
             </a:r>
-            <a:endParaRPr lang="en-US" sz="1100" dirty="0"/>
+            <a:endParaRPr lang="en-US" sz="1300" dirty="0"/>
           </a:p>
           <a:p>
             <a:pPr marL="342900" indent="-342900">
               <a:spcAft>
-                <a:spcPts val="400"/>
+                <a:spcPts val="500"/>
               </a:spcAft>
               <a:buSzPct val="100000"/>
               <a:buChar char="•"/>
             </a:pPr>
             <a:r>
-              <a:rPr lang="en-US" sz="1100" dirty="0">
+              <a:rPr lang="en-US" sz="1300" dirty="0">
                 <a:solidFill>
                   <a:srgbClr val="1A1A1A"/>
                 </a:solidFill>
               </a:rPr>
               <a:t>Concave-up curve → trapezoids lie above → overestimate.</a:t>
             </a:r>
-            <a:endParaRPr lang="en-US" sz="1100" dirty="0"/>
+            <a:endParaRPr lang="en-US" sz="1300" dirty="0"/>
           </a:p>
           <a:p>
             <a:pPr marL="342900" indent="-342900">
               <a:spcAft>
-                <a:spcPts val="400"/>
+                <a:spcPts val="500"/>
               </a:spcAft>
               <a:buSzPct val="100000"/>
               <a:buChar char="•"/>
             </a:pPr>
             <a:r>
-              <a:rPr lang="en-US" sz="1100" dirty="0">
+              <a:rPr lang="en-US" sz="1300" dirty="0">
                 <a:solidFill>
                   <a:srgbClr val="1A1A1A"/>
                 </a:solidFill>
               </a:rPr>
               <a:t>Concave-down curve → trapezoids lie below → underestimate.</a:t>
             </a:r>
-            <a:endParaRPr lang="en-US" sz="1100" dirty="0"/>
+            <a:endParaRPr lang="en-US" sz="1300" dirty="0"/>
           </a:p>
           <a:p>
             <a:pPr marL="342900" indent="-342900">
               <a:spcAft>
-                <a:spcPts val="400"/>
+                <a:spcPts val="500"/>
               </a:spcAft>
               <a:buSzPct val="100000"/>
               <a:buChar char="•"/>
             </a:pPr>
             <a:r>
-              <a:rPr lang="en-US" sz="1100" dirty="0">
+              <a:rPr lang="en-US" sz="1300" dirty="0">
                 <a:solidFill>
                   <a:srgbClr val="1A1A1A"/>
                 </a:solidFill>
               </a:rPr>
               <a:t>More subintervals (smaller h) → closer approximation.</a:t>
             </a:r>
-            <a:endParaRPr lang="en-US" sz="1100" dirty="0"/>
+            <a:endParaRPr lang="en-US" sz="1300" dirty="0"/>
           </a:p>
         </p:txBody>
       </p:sp>
@@ -2583,7 +2680,7 @@
         <p:spPr>
           <a:xfrm>
             <a:off x="0" y="0"/>
-            <a:ext cx="9144000" cy="658368"/>
+            <a:ext cx="12192000" cy="804672"/>
           </a:xfrm>
           <a:prstGeom prst="rect">
             <a:avLst/>
@@ -2602,31 +2699,31 @@
         </p:nvSpPr>
         <p:spPr>
           <a:xfrm>
-            <a:off x="384048" y="0"/>
-            <a:ext cx="8375904" cy="658368"/>
-          </a:xfrm>
-          <a:prstGeom prst="rect">
-            <a:avLst/>
-          </a:prstGeom>
-          <a:noFill/>
-          <a:ln/>
-        </p:spPr>
-        <p:txBody>
-          <a:bodyPr wrap="square" rtlCol="0" anchor="ctr"/>
-          <a:lstStyle/>
-          <a:p>
-            <a:pPr indent="0" marL="0">
-              <a:buNone/>
-            </a:pPr>
-            <a:r>
-              <a:rPr lang="en-US" sz="1800" b="1" dirty="0">
+            <a:off x="502920" y="0"/>
+            <a:ext cx="11186160" cy="804672"/>
+          </a:xfrm>
+          <a:prstGeom prst="rect">
+            <a:avLst/>
+          </a:prstGeom>
+          <a:noFill/>
+          <a:ln/>
+        </p:spPr>
+        <p:txBody>
+          <a:bodyPr wrap="square" rtlCol="0" anchor="ctr"/>
+          <a:lstStyle/>
+          <a:p>
+            <a:pPr indent="0" marL="0">
+              <a:buNone/>
+            </a:pPr>
+            <a:r>
+              <a:rPr lang="en-US" sz="2200" b="1" dirty="0">
                 <a:solidFill>
                   <a:srgbClr val="FFFFFF"/>
                 </a:solidFill>
               </a:rPr>
               <a:t>Learning Intention &amp; Success Criteria</a:t>
             </a:r>
-            <a:endParaRPr lang="en-US" sz="1800" dirty="0"/>
+            <a:endParaRPr lang="en-US" sz="2200" dirty="0"/>
           </a:p>
         </p:txBody>
       </p:sp>
@@ -2638,11 +2735,13 @@
         </p:nvSpPr>
         <p:spPr>
           <a:xfrm>
-            <a:off x="384048" y="841248"/>
-            <a:ext cx="8375904" cy="640080"/>
-          </a:xfrm>
-          <a:prstGeom prst="rect">
-            <a:avLst/>
+            <a:off x="502920" y="1005840"/>
+            <a:ext cx="11186160" cy="749808"/>
+          </a:xfrm>
+          <a:prstGeom prst="roundRect">
+            <a:avLst>
+              <a:gd name="adj" fmla="val 12195"/>
+            </a:avLst>
           </a:prstGeom>
           <a:solidFill>
             <a:srgbClr val="EBF4FF"/>
@@ -2658,80 +2757,80 @@
         </p:nvSpPr>
         <p:spPr>
           <a:xfrm>
-            <a:off x="512064" y="877824"/>
-            <a:ext cx="8119872" cy="566928"/>
-          </a:xfrm>
-          <a:prstGeom prst="rect">
-            <a:avLst/>
-          </a:prstGeom>
-          <a:noFill/>
-          <a:ln/>
-        </p:spPr>
-        <p:txBody>
-          <a:bodyPr wrap="square" rtlCol="0" anchor="ctr"/>
-          <a:lstStyle/>
-          <a:p>
-            <a:pPr indent="0" marL="0">
-              <a:buNone/>
-            </a:pPr>
-            <a:r>
-              <a:rPr lang="en-US" sz="1200" i="1" dirty="0">
+            <a:off x="667512" y="1060704"/>
+            <a:ext cx="10856976" cy="640080"/>
+          </a:xfrm>
+          <a:prstGeom prst="rect">
+            <a:avLst/>
+          </a:prstGeom>
+          <a:noFill/>
+          <a:ln/>
+        </p:spPr>
+        <p:txBody>
+          <a:bodyPr wrap="square" rtlCol="0" anchor="ctr"/>
+          <a:lstStyle/>
+          <a:p>
+            <a:pPr indent="0" marL="0">
+              <a:buNone/>
+            </a:pPr>
+            <a:r>
+              <a:rPr lang="en-US" sz="1300" dirty="0">
                 <a:solidFill>
                   <a:srgbClr val="1A1A1A"/>
                 </a:solidFill>
               </a:rPr>
               <a:t>Use the trapezoidal rule to approximate definite integrals and judge when the approximation is likely to overestimate or underestimate.</a:t>
             </a:r>
+            <a:endParaRPr lang="en-US" sz="1300" dirty="0"/>
+          </a:p>
+        </p:txBody>
+      </p:sp>
+      <p:sp>
+        <p:nvSpPr>
+          <p:cNvPr id="6" name="Text 4"/>
+          <p:cNvSpPr/>
+          <p:nvPr/>
+        </p:nvSpPr>
+        <p:spPr>
+          <a:xfrm>
+            <a:off x="502920" y="1883664"/>
+            <a:ext cx="11186160" cy="329184"/>
+          </a:xfrm>
+          <a:prstGeom prst="rect">
+            <a:avLst/>
+          </a:prstGeom>
+          <a:noFill/>
+          <a:ln/>
+        </p:spPr>
+        <p:txBody>
+          <a:bodyPr wrap="square" rtlCol="0" anchor="ctr"/>
+          <a:lstStyle/>
+          <a:p>
+            <a:pPr indent="0" marL="0">
+              <a:buNone/>
+            </a:pPr>
+            <a:r>
+              <a:rPr lang="en-US" sz="1200" b="1" dirty="0">
+                <a:solidFill>
+                  <a:srgbClr val="1B3A6B"/>
+                </a:solidFill>
+              </a:rPr>
+              <a:t>By the end of this lesson you will be able to:</a:t>
+            </a:r>
             <a:endParaRPr lang="en-US" sz="1200" dirty="0"/>
           </a:p>
         </p:txBody>
       </p:sp>
       <p:sp>
         <p:nvSpPr>
-          <p:cNvPr id="6" name="Text 4"/>
-          <p:cNvSpPr/>
-          <p:nvPr/>
-        </p:nvSpPr>
-        <p:spPr>
-          <a:xfrm>
-            <a:off x="384048" y="1591056"/>
-            <a:ext cx="8375904" cy="274320"/>
-          </a:xfrm>
-          <a:prstGeom prst="rect">
-            <a:avLst/>
-          </a:prstGeom>
-          <a:noFill/>
-          <a:ln/>
-        </p:spPr>
-        <p:txBody>
-          <a:bodyPr wrap="square" rtlCol="0" anchor="ctr"/>
-          <a:lstStyle/>
-          <a:p>
-            <a:pPr indent="0" marL="0">
-              <a:buNone/>
-            </a:pPr>
-            <a:r>
-              <a:rPr lang="en-US" sz="1050" b="1" dirty="0">
-                <a:solidFill>
-                  <a:srgbClr val="1B3A6B"/>
-                </a:solidFill>
-              </a:rPr>
-              <a:t>By the end of this lesson you will be able to:</a:t>
-            </a:r>
-            <a:endParaRPr lang="en-US" sz="1050" dirty="0"/>
-          </a:p>
-        </p:txBody>
-      </p:sp>
-      <p:sp>
-        <p:nvSpPr>
           <p:cNvPr id="7" name="Text 5"/>
           <p:cNvSpPr/>
           <p:nvPr/>
         </p:nvSpPr>
         <p:spPr>
           <a:xfrm>
-            <a:off x="475488" y="1901952"/>
-            <a:ext cx="8193024" cy="3040380"/>
+            <a:off x="630936" y="2249424"/>
+            <a:ext cx="10930128" cy="4352544"/>
           </a:xfrm>
           <a:prstGeom prst="rect">
             <a:avLst/>
@@ -2745,110 +2844,110 @@
           <a:p>
             <a:pPr marL="342900" indent="-342900">
               <a:spcAft>
-                <a:spcPts val="200"/>
+                <a:spcPts val="400"/>
               </a:spcAft>
               <a:buSzPct val="100000"/>
               <a:buChar char="•"/>
             </a:pPr>
             <a:r>
-              <a:rPr lang="en-US" sz="1050" dirty="0">
+              <a:rPr lang="en-US" sz="1200" dirty="0">
                 <a:solidFill>
                   <a:srgbClr val="1A1A1A"/>
                 </a:solidFill>
               </a:rPr>
               <a:t>Identify the subinterval width h from limits and number of subintervals.</a:t>
             </a:r>
-            <a:endParaRPr lang="en-US" sz="1050" dirty="0"/>
+            <a:endParaRPr lang="en-US" sz="1200" dirty="0"/>
           </a:p>
           <a:p>
             <a:pPr marL="342900" indent="-342900">
               <a:spcAft>
-                <a:spcPts val="200"/>
+                <a:spcPts val="400"/>
               </a:spcAft>
               <a:buSzPct val="100000"/>
               <a:buChar char="•"/>
             </a:pPr>
             <a:r>
-              <a:rPr lang="en-US" sz="1050" dirty="0">
+              <a:rPr lang="en-US" sz="1200" dirty="0">
                 <a:solidFill>
                   <a:srgbClr val="1A1A1A"/>
                 </a:solidFill>
               </a:rPr>
               <a:t>Apply the trapezoidal rule using endpoint and interior y-values.</a:t>
             </a:r>
-            <a:endParaRPr lang="en-US" sz="1050" dirty="0"/>
+            <a:endParaRPr lang="en-US" sz="1200" dirty="0"/>
           </a:p>
           <a:p>
             <a:pPr marL="342900" indent="-342900">
               <a:spcAft>
-                <a:spcPts val="200"/>
+                <a:spcPts val="400"/>
               </a:spcAft>
               <a:buSzPct val="100000"/>
               <a:buChar char="•"/>
             </a:pPr>
             <a:r>
-              <a:rPr lang="en-US" sz="1050" dirty="0">
+              <a:rPr lang="en-US" sz="1200" dirty="0">
                 <a:solidFill>
                   <a:srgbClr val="1A1A1A"/>
                 </a:solidFill>
               </a:rPr>
               <a:t>Use one trapezoid and two trapezoids in simple function examples.</a:t>
             </a:r>
-            <a:endParaRPr lang="en-US" sz="1050" dirty="0"/>
+            <a:endParaRPr lang="en-US" sz="1200" dirty="0"/>
           </a:p>
           <a:p>
             <a:pPr marL="342900" indent="-342900">
               <a:spcAft>
-                <a:spcPts val="200"/>
+                <a:spcPts val="400"/>
               </a:spcAft>
               <a:buSzPct val="100000"/>
               <a:buChar char="•"/>
             </a:pPr>
             <a:r>
-              <a:rPr lang="en-US" sz="1050" dirty="0">
+              <a:rPr lang="en-US" sz="1200" dirty="0">
                 <a:solidFill>
                   <a:srgbClr val="1A1A1A"/>
                 </a:solidFill>
               </a:rPr>
               <a:t>Approximate an integral from a table of values.</a:t>
             </a:r>
-            <a:endParaRPr lang="en-US" sz="1050" dirty="0"/>
+            <a:endParaRPr lang="en-US" sz="1200" dirty="0"/>
           </a:p>
           <a:p>
             <a:pPr marL="342900" indent="-342900">
               <a:spcAft>
-                <a:spcPts val="200"/>
+                <a:spcPts val="400"/>
               </a:spcAft>
               <a:buSzPct val="100000"/>
               <a:buChar char="•"/>
             </a:pPr>
             <a:r>
-              <a:rPr lang="en-US" sz="1050" dirty="0">
+              <a:rPr lang="en-US" sz="1200" dirty="0">
                 <a:solidFill>
                   <a:srgbClr val="1A1A1A"/>
                 </a:solidFill>
               </a:rPr>
               <a:t>Recognise common coefficient errors in the trapezoidal formula.</a:t>
             </a:r>
-            <a:endParaRPr lang="en-US" sz="1050" dirty="0"/>
+            <a:endParaRPr lang="en-US" sz="1200" dirty="0"/>
           </a:p>
           <a:p>
             <a:pPr marL="342900" indent="-342900">
               <a:spcAft>
-                <a:spcPts val="200"/>
+                <a:spcPts val="400"/>
               </a:spcAft>
               <a:buSzPct val="100000"/>
               <a:buChar char="•"/>
             </a:pPr>
             <a:r>
-              <a:rPr lang="en-US" sz="1050" dirty="0">
+              <a:rPr lang="en-US" sz="1200" dirty="0">
                 <a:solidFill>
                   <a:srgbClr val="1A1A1A"/>
                 </a:solidFill>
               </a:rPr>
               <a:t>Use concavity to decide whether the approximation overestimates or underestimates.</a:t>
             </a:r>
-            <a:endParaRPr lang="en-US" sz="1050" dirty="0"/>
+            <a:endParaRPr lang="en-US" sz="1200" dirty="0"/>
           </a:p>
         </p:txBody>
       </p:sp>
@@ -2886,7 +2985,7 @@
         <p:spPr>
           <a:xfrm>
             <a:off x="0" y="0"/>
-            <a:ext cx="9144000" cy="658368"/>
+            <a:ext cx="12192000" cy="804672"/>
           </a:xfrm>
           <a:prstGeom prst="rect">
             <a:avLst/>
@@ -2905,31 +3004,31 @@
         </p:nvSpPr>
         <p:spPr>
           <a:xfrm>
-            <a:off x="384048" y="0"/>
-            <a:ext cx="8375904" cy="658368"/>
-          </a:xfrm>
-          <a:prstGeom prst="rect">
-            <a:avLst/>
-          </a:prstGeom>
-          <a:noFill/>
-          <a:ln/>
-        </p:spPr>
-        <p:txBody>
-          <a:bodyPr wrap="square" rtlCol="0" anchor="ctr"/>
-          <a:lstStyle/>
-          <a:p>
-            <a:pPr indent="0" marL="0">
-              <a:buNone/>
-            </a:pPr>
-            <a:r>
-              <a:rPr lang="en-US" sz="1800" b="1" dirty="0">
+            <a:off x="502920" y="0"/>
+            <a:ext cx="11186160" cy="804672"/>
+          </a:xfrm>
+          <a:prstGeom prst="rect">
+            <a:avLst/>
+          </a:prstGeom>
+          <a:noFill/>
+          <a:ln/>
+        </p:spPr>
+        <p:txBody>
+          <a:bodyPr wrap="square" rtlCol="0" anchor="ctr"/>
+          <a:lstStyle/>
+          <a:p>
+            <a:pPr indent="0" marL="0">
+              <a:buNone/>
+            </a:pPr>
+            <a:r>
+              <a:rPr lang="en-US" sz="2200" b="1" dirty="0">
                 <a:solidFill>
                   <a:srgbClr val="FFFFFF"/>
                 </a:solidFill>
               </a:rPr>
               <a:t>The Trapezoidal Rule – Key Formula</a:t>
             </a:r>
-            <a:endParaRPr lang="en-US" sz="1800" dirty="0"/>
+            <a:endParaRPr lang="en-US" sz="2200" dirty="0"/>
           </a:p>
         </p:txBody>
       </p:sp>
@@ -2941,31 +3040,31 @@
         </p:nvSpPr>
         <p:spPr>
           <a:xfrm>
-            <a:off x="384048" y="841248"/>
-            <a:ext cx="8375904" cy="347472"/>
-          </a:xfrm>
-          <a:prstGeom prst="rect">
-            <a:avLst/>
-          </a:prstGeom>
-          <a:noFill/>
-          <a:ln/>
-        </p:spPr>
-        <p:txBody>
-          <a:bodyPr wrap="square" rtlCol="0" anchor="ctr"/>
-          <a:lstStyle/>
-          <a:p>
-            <a:pPr indent="0" marL="0">
-              <a:buNone/>
-            </a:pPr>
-            <a:r>
-              <a:rPr lang="en-US" sz="1100" dirty="0">
+            <a:off x="502920" y="1005840"/>
+            <a:ext cx="11186160" cy="402336"/>
+          </a:xfrm>
+          <a:prstGeom prst="rect">
+            <a:avLst/>
+          </a:prstGeom>
+          <a:noFill/>
+          <a:ln/>
+        </p:spPr>
+        <p:txBody>
+          <a:bodyPr wrap="square" rtlCol="0" anchor="ctr"/>
+          <a:lstStyle/>
+          <a:p>
+            <a:pPr indent="0" marL="0">
+              <a:buNone/>
+            </a:pPr>
+            <a:r>
+              <a:rPr lang="en-US" sz="1300" dirty="0">
                 <a:solidFill>
                   <a:srgbClr val="1A1A1A"/>
                 </a:solidFill>
               </a:rPr>
               <a:t>The trapezoidal rule approximates a definite integral by replacing a curve with straight line segments and adding the areas of trapezoids.</a:t>
             </a:r>
-            <a:endParaRPr lang="en-US" sz="1100" dirty="0"/>
+            <a:endParaRPr lang="en-US" sz="1300" dirty="0"/>
           </a:p>
         </p:txBody>
       </p:sp>
@@ -2977,31 +3076,31 @@
         </p:nvSpPr>
         <p:spPr>
           <a:xfrm>
-            <a:off x="384048" y="1207008"/>
-            <a:ext cx="8375904" cy="347472"/>
-          </a:xfrm>
-          <a:prstGeom prst="rect">
-            <a:avLst/>
-          </a:prstGeom>
-          <a:noFill/>
-          <a:ln/>
-        </p:spPr>
-        <p:txBody>
-          <a:bodyPr wrap="square" rtlCol="0" anchor="ctr"/>
-          <a:lstStyle/>
-          <a:p>
-            <a:pPr indent="0" marL="0">
-              <a:buNone/>
-            </a:pPr>
-            <a:r>
-              <a:rPr lang="en-US" sz="1100" i="1" dirty="0">
+            <a:off x="502920" y="1444752"/>
+            <a:ext cx="11186160" cy="402336"/>
+          </a:xfrm>
+          <a:prstGeom prst="rect">
+            <a:avLst/>
+          </a:prstGeom>
+          <a:noFill/>
+          <a:ln/>
+        </p:spPr>
+        <p:txBody>
+          <a:bodyPr wrap="square" rtlCol="0" anchor="ctr"/>
+          <a:lstStyle/>
+          <a:p>
+            <a:pPr indent="0" marL="0">
+              <a:buNone/>
+            </a:pPr>
+            <a:r>
+              <a:rPr lang="en-US" sz="1300" dirty="0">
                 <a:solidFill>
                   <a:srgbClr val="555555"/>
                 </a:solidFill>
               </a:rPr>
               <a:t>Endpoint y-values are used once. Interior y-values are used twice because each interior height belongs to two neighbouring trapezoids.</a:t>
             </a:r>
-            <a:endParaRPr lang="en-US" sz="1100" dirty="0"/>
+            <a:endParaRPr lang="en-US" sz="1300" dirty="0"/>
           </a:p>
         </p:txBody>
       </p:sp>
@@ -3013,11 +3112,13 @@
         </p:nvSpPr>
         <p:spPr>
           <a:xfrm>
-            <a:off x="384048" y="1664208"/>
-            <a:ext cx="8375904" cy="658368"/>
-          </a:xfrm>
-          <a:prstGeom prst="rect">
-            <a:avLst/>
+            <a:off x="502920" y="1956816"/>
+            <a:ext cx="11186160" cy="804672"/>
+          </a:xfrm>
+          <a:prstGeom prst="roundRect">
+            <a:avLst>
+              <a:gd name="adj" fmla="val 11364"/>
+            </a:avLst>
           </a:prstGeom>
           <a:solidFill>
             <a:srgbClr val="FFF8E1"/>
@@ -3033,24 +3134,24 @@
         </p:nvSpPr>
         <p:spPr>
           <a:xfrm>
-            <a:off x="493776" y="1719072"/>
-            <a:ext cx="8156448" cy="548640"/>
-          </a:xfrm>
-          <a:prstGeom prst="rect">
-            <a:avLst/>
-          </a:prstGeom>
-          <a:noFill/>
-          <a:ln/>
-        </p:spPr>
-        <p:txBody>
-          <a:bodyPr wrap="square" rtlCol="0" anchor="ctr"/>
-          <a:lstStyle/>
-          <a:p>
-            <a:pPr indent="0" marL="0">
-              <a:buNone/>
-            </a:pPr>
-            <a:r>
-              <a:rPr lang="en-US" sz="1300" dirty="0">
+            <a:off x="649224" y="2029968"/>
+            <a:ext cx="10893552" cy="658368"/>
+          </a:xfrm>
+          <a:prstGeom prst="rect">
+            <a:avLst/>
+          </a:prstGeom>
+          <a:noFill/>
+          <a:ln/>
+        </p:spPr>
+        <p:txBody>
+          <a:bodyPr wrap="square" rtlCol="0" anchor="ctr"/>
+          <a:lstStyle/>
+          <a:p>
+            <a:pPr indent="0" marL="0">
+              <a:buNone/>
+            </a:pPr>
+            <a:r>
+              <a:rPr lang="en-US" sz="1600" dirty="0">
                 <a:solidFill>
                   <a:srgbClr val="1A1A1A"/>
                 </a:solidFill>
@@ -3058,9 +3159,9 @@
                 <a:ea typeface="Cambria Math" pitchFamily="34" charset="-122"/>
                 <a:cs typeface="Cambria Math" pitchFamily="34" charset="-120"/>
               </a:rPr>
-              <a:t>∫ f(x) dx ≈ h/2[y₀+2y₁+2y₂+⋯+2yₙ₋₁+yₙ]</a:t>
-            </a:r>
-            <a:endParaRPr lang="en-US" sz="1300" dirty="0"/>
+              <a:t>∫ f(x) dx ≈ h/2[y₀+2y₁+2y₂+⋯+2yₙ₋₁+yₙ]</a:t>
+            </a:r>
+            <a:endParaRPr lang="en-US" sz="1600" dirty="0"/>
           </a:p>
         </p:txBody>
       </p:sp>
@@ -3072,8 +3173,8 @@
         </p:nvSpPr>
         <p:spPr>
           <a:xfrm>
-            <a:off x="384048" y="2432304"/>
-            <a:ext cx="3936675" cy="475488"/>
+            <a:off x="502920" y="2889504"/>
+            <a:ext cx="5257495" cy="594360"/>
           </a:xfrm>
           <a:prstGeom prst="rect">
             <a:avLst/>
@@ -3092,24 +3193,24 @@
         </p:nvSpPr>
         <p:spPr>
           <a:xfrm>
-            <a:off x="493776" y="2487168"/>
-            <a:ext cx="3717219" cy="365760"/>
-          </a:xfrm>
-          <a:prstGeom prst="rect">
-            <a:avLst/>
-          </a:prstGeom>
-          <a:noFill/>
-          <a:ln/>
-        </p:spPr>
-        <p:txBody>
-          <a:bodyPr wrap="square" rtlCol="0" anchor="ctr"/>
-          <a:lstStyle/>
-          <a:p>
-            <a:pPr indent="0" marL="0">
-              <a:buNone/>
-            </a:pPr>
-            <a:r>
-              <a:rPr lang="en-US" sz="1300" dirty="0">
+            <a:off x="649224" y="2962656"/>
+            <a:ext cx="4964887" cy="448056"/>
+          </a:xfrm>
+          <a:prstGeom prst="rect">
+            <a:avLst/>
+          </a:prstGeom>
+          <a:noFill/>
+          <a:ln/>
+        </p:spPr>
+        <p:txBody>
+          <a:bodyPr wrap="square" rtlCol="0" anchor="ctr"/>
+          <a:lstStyle/>
+          <a:p>
+            <a:pPr indent="0" marL="0">
+              <a:buNone/>
+            </a:pPr>
+            <a:r>
+              <a:rPr lang="en-US" sz="1400" dirty="0">
                 <a:solidFill>
                   <a:srgbClr val="1A1A1A"/>
                 </a:solidFill>
@@ -3119,7 +3220,7 @@
               </a:rPr>
               <a:t>h=(b-a)/(n)</a:t>
             </a:r>
-            <a:endParaRPr lang="en-US" sz="1300" dirty="0"/>
+            <a:endParaRPr lang="en-US" sz="1400" dirty="0"/>
           </a:p>
         </p:txBody>
       </p:sp>
@@ -3131,8 +3232,8 @@
         </p:nvSpPr>
         <p:spPr>
           <a:xfrm>
-            <a:off x="4572000" y="2432304"/>
-            <a:ext cx="3936675" cy="475488"/>
+            <a:off x="6096000" y="2889504"/>
+            <a:ext cx="5257495" cy="594360"/>
           </a:xfrm>
           <a:prstGeom prst="rect">
             <a:avLst/>
@@ -3151,24 +3252,24 @@
         </p:nvSpPr>
         <p:spPr>
           <a:xfrm>
-            <a:off x="4681728" y="2487168"/>
-            <a:ext cx="3717219" cy="365760"/>
-          </a:xfrm>
-          <a:prstGeom prst="rect">
-            <a:avLst/>
-          </a:prstGeom>
-          <a:noFill/>
-          <a:ln/>
-        </p:spPr>
-        <p:txBody>
-          <a:bodyPr wrap="square" rtlCol="0" anchor="ctr"/>
-          <a:lstStyle/>
-          <a:p>
-            <a:pPr indent="0" marL="0">
-              <a:buNone/>
-            </a:pPr>
-            <a:r>
-              <a:rPr lang="en-US" sz="1300" dirty="0">
+            <a:off x="6242304" y="2962656"/>
+            <a:ext cx="4964887" cy="448056"/>
+          </a:xfrm>
+          <a:prstGeom prst="rect">
+            <a:avLst/>
+          </a:prstGeom>
+          <a:noFill/>
+          <a:ln/>
+        </p:spPr>
+        <p:txBody>
+          <a:bodyPr wrap="square" rtlCol="0" anchor="ctr"/>
+          <a:lstStyle/>
+          <a:p>
+            <a:pPr indent="0" marL="0">
+              <a:buNone/>
+            </a:pPr>
+            <a:r>
+              <a:rPr lang="en-US" sz="1400" dirty="0">
                 <a:solidFill>
                   <a:srgbClr val="1A1A1A"/>
                 </a:solidFill>
@@ -3178,7 +3279,7 @@
               </a:rPr>
               <a:t>one subinterval: h/2(y₀+y₁)</a:t>
             </a:r>
-            <a:endParaRPr lang="en-US" sz="1300" dirty="0"/>
+            <a:endParaRPr lang="en-US" sz="1400" dirty="0"/>
           </a:p>
         </p:txBody>
       </p:sp>
@@ -3216,7 +3317,7 @@
         <p:spPr>
           <a:xfrm>
             <a:off x="0" y="0"/>
-            <a:ext cx="9144000" cy="658368"/>
+            <a:ext cx="12192000" cy="804672"/>
           </a:xfrm>
           <a:prstGeom prst="rect">
             <a:avLst/>
@@ -3235,31 +3336,31 @@
         </p:nvSpPr>
         <p:spPr>
           <a:xfrm>
-            <a:off x="384048" y="0"/>
-            <a:ext cx="8375904" cy="658368"/>
-          </a:xfrm>
-          <a:prstGeom prst="rect">
-            <a:avLst/>
-          </a:prstGeom>
-          <a:noFill/>
-          <a:ln/>
-        </p:spPr>
-        <p:txBody>
-          <a:bodyPr wrap="square" rtlCol="0" anchor="ctr"/>
-          <a:lstStyle/>
-          <a:p>
-            <a:pPr indent="0" marL="0">
-              <a:buNone/>
-            </a:pPr>
-            <a:r>
-              <a:rPr lang="en-US" sz="1800" b="1" dirty="0">
+            <a:off x="502920" y="0"/>
+            <a:ext cx="11186160" cy="804672"/>
+          </a:xfrm>
+          <a:prstGeom prst="rect">
+            <a:avLst/>
+          </a:prstGeom>
+          <a:noFill/>
+          <a:ln/>
+        </p:spPr>
+        <p:txBody>
+          <a:bodyPr wrap="square" rtlCol="0" anchor="ctr"/>
+          <a:lstStyle/>
+          <a:p>
+            <a:pPr indent="0" marL="0">
+              <a:buNone/>
+            </a:pPr>
+            <a:r>
+              <a:rPr lang="en-US" sz="2200" b="1" dirty="0">
                 <a:solidFill>
                   <a:srgbClr val="FFFFFF"/>
                 </a:solidFill>
               </a:rPr>
               <a:t>Worked Example 1: One Trapezoid</a:t>
             </a:r>
-            <a:endParaRPr lang="en-US" sz="1800" dirty="0"/>
+            <a:endParaRPr lang="en-US" sz="2200" dirty="0"/>
           </a:p>
         </p:txBody>
       </p:sp>
@@ -3271,11 +3372,13 @@
         </p:nvSpPr>
         <p:spPr>
           <a:xfrm>
-            <a:off x="384048" y="841248"/>
-            <a:ext cx="8375904" cy="493776"/>
-          </a:xfrm>
-          <a:prstGeom prst="rect">
-            <a:avLst/>
+            <a:off x="502920" y="1005840"/>
+            <a:ext cx="11186160" cy="603504"/>
+          </a:xfrm>
+          <a:prstGeom prst="roundRect">
+            <a:avLst>
+              <a:gd name="adj" fmla="val 15152"/>
+            </a:avLst>
           </a:prstGeom>
           <a:solidFill>
             <a:srgbClr val="EBF4FF"/>
@@ -3291,24 +3394,24 @@
         </p:nvSpPr>
         <p:spPr>
           <a:xfrm>
-            <a:off x="512064" y="877824"/>
-            <a:ext cx="8119872" cy="420624"/>
-          </a:xfrm>
-          <a:prstGeom prst="rect">
-            <a:avLst/>
-          </a:prstGeom>
-          <a:noFill/>
-          <a:ln/>
-        </p:spPr>
-        <p:txBody>
-          <a:bodyPr wrap="square" rtlCol="0" anchor="ctr"/>
-          <a:lstStyle/>
-          <a:p>
-            <a:pPr indent="0" marL="0">
-              <a:buNone/>
-            </a:pPr>
-            <a:r>
-              <a:rPr lang="en-US" sz="1200" dirty="0">
+            <a:off x="667512" y="1060704"/>
+            <a:ext cx="10856976" cy="493776"/>
+          </a:xfrm>
+          <a:prstGeom prst="rect">
+            <a:avLst/>
+          </a:prstGeom>
+          <a:noFill/>
+          <a:ln/>
+        </p:spPr>
+        <p:txBody>
+          <a:bodyPr wrap="square" rtlCol="0" anchor="ctr"/>
+          <a:lstStyle/>
+          <a:p>
+            <a:pPr indent="0" marL="0">
+              <a:buNone/>
+            </a:pPr>
+            <a:r>
+              <a:rPr lang="en-US" sz="1300" dirty="0">
                 <a:solidFill>
                   <a:srgbClr val="1A1A1A"/>
                 </a:solidFill>
@@ -3316,7 +3419,43 @@
                 <a:ea typeface="Cambria Math" pitchFamily="34" charset="-122"/>
                 <a:cs typeface="Cambria Math" pitchFamily="34" charset="-120"/>
               </a:rPr>
-              <a:t>Use one trapezoid to approximate ∫ x² dx.</a:t>
+              <a:t>Use one trapezoid to approximate ∫ x² dx.</a:t>
+            </a:r>
+            <a:endParaRPr lang="en-US" sz="1300" dirty="0"/>
+          </a:p>
+        </p:txBody>
+      </p:sp>
+      <p:sp>
+        <p:nvSpPr>
+          <p:cNvPr id="6" name="Text 4"/>
+          <p:cNvSpPr/>
+          <p:nvPr/>
+        </p:nvSpPr>
+        <p:spPr>
+          <a:xfrm>
+            <a:off x="502920" y="1755648"/>
+            <a:ext cx="6040526" cy="402336"/>
+          </a:xfrm>
+          <a:prstGeom prst="rect">
+            <a:avLst/>
+          </a:prstGeom>
+          <a:noFill/>
+          <a:ln/>
+        </p:spPr>
+        <p:txBody>
+          <a:bodyPr wrap="square" rtlCol="0" anchor="ctr"/>
+          <a:lstStyle/>
+          <a:p>
+            <a:pPr indent="0" marL="0">
+              <a:buNone/>
+            </a:pPr>
+            <a:r>
+              <a:rPr lang="en-US" sz="1200" dirty="0">
+                <a:solidFill>
+                  <a:srgbClr val="1A1A1A"/>
+                </a:solidFill>
+              </a:rPr>
+              <a:t>1.  With one subinterval, the width is 2.</a:t>
             </a:r>
             <a:endParaRPr lang="en-US" sz="1200" dirty="0"/>
           </a:p>
@@ -3324,50 +3463,14 @@
       </p:sp>
       <p:sp>
         <p:nvSpPr>
-          <p:cNvPr id="6" name="Text 4"/>
-          <p:cNvSpPr/>
-          <p:nvPr/>
-        </p:nvSpPr>
-        <p:spPr>
-          <a:xfrm>
-            <a:off x="384048" y="1444752"/>
-            <a:ext cx="4522988" cy="347472"/>
-          </a:xfrm>
-          <a:prstGeom prst="rect">
-            <a:avLst/>
-          </a:prstGeom>
-          <a:noFill/>
-          <a:ln/>
-        </p:spPr>
-        <p:txBody>
-          <a:bodyPr wrap="square" rtlCol="0" anchor="ctr"/>
-          <a:lstStyle/>
-          <a:p>
-            <a:pPr indent="0" marL="0">
-              <a:buNone/>
-            </a:pPr>
-            <a:r>
-              <a:rPr lang="en-US" sz="1100" dirty="0">
-                <a:solidFill>
-                  <a:srgbClr val="1A1A1A"/>
-                </a:solidFill>
-              </a:rPr>
-              <a:t>1.  With one subinterval, the width is 2.</a:t>
-            </a:r>
-            <a:endParaRPr lang="en-US" sz="1100" dirty="0"/>
-          </a:p>
-        </p:txBody>
-      </p:sp>
-      <p:sp>
-        <p:nvSpPr>
           <p:cNvPr id="7" name="Shape 5"/>
           <p:cNvSpPr/>
           <p:nvPr/>
         </p:nvSpPr>
         <p:spPr>
           <a:xfrm>
-            <a:off x="5158313" y="1444752"/>
-            <a:ext cx="3434121" cy="329184"/>
+            <a:off x="6879031" y="1755648"/>
+            <a:ext cx="4586326" cy="384048"/>
           </a:xfrm>
           <a:prstGeom prst="rect">
             <a:avLst/>
@@ -3386,24 +3489,24 @@
         </p:nvSpPr>
         <p:spPr>
           <a:xfrm>
-            <a:off x="5249753" y="1472184"/>
-            <a:ext cx="3251241" cy="274320"/>
-          </a:xfrm>
-          <a:prstGeom prst="rect">
-            <a:avLst/>
-          </a:prstGeom>
-          <a:noFill/>
-          <a:ln/>
-        </p:spPr>
-        <p:txBody>
-          <a:bodyPr wrap="square" rtlCol="0" anchor="ctr"/>
-          <a:lstStyle/>
-          <a:p>
-            <a:pPr indent="0" marL="0">
-              <a:buNone/>
-            </a:pPr>
-            <a:r>
-              <a:rPr lang="en-US" sz="1200" dirty="0">
+            <a:off x="7007047" y="1783080"/>
+            <a:ext cx="4330294" cy="329184"/>
+          </a:xfrm>
+          <a:prstGeom prst="rect">
+            <a:avLst/>
+          </a:prstGeom>
+          <a:noFill/>
+          <a:ln/>
+        </p:spPr>
+        <p:txBody>
+          <a:bodyPr wrap="square" rtlCol="0" anchor="ctr"/>
+          <a:lstStyle/>
+          <a:p>
+            <a:pPr indent="0" marL="0">
+              <a:buNone/>
+            </a:pPr>
+            <a:r>
+              <a:rPr lang="en-US" sz="1300" dirty="0">
                 <a:solidFill>
                   <a:srgbClr val="1A1A1A"/>
                 </a:solidFill>
@@ -3413,56 +3516,56 @@
               </a:rPr>
               <a:t>h=2</a:t>
             </a:r>
+            <a:endParaRPr lang="en-US" sz="1300" dirty="0"/>
+          </a:p>
+        </p:txBody>
+      </p:sp>
+      <p:sp>
+        <p:nvSpPr>
+          <p:cNvPr id="9" name="Text 7"/>
+          <p:cNvSpPr/>
+          <p:nvPr/>
+        </p:nvSpPr>
+        <p:spPr>
+          <a:xfrm>
+            <a:off x="502920" y="2231136"/>
+            <a:ext cx="6040526" cy="402336"/>
+          </a:xfrm>
+          <a:prstGeom prst="rect">
+            <a:avLst/>
+          </a:prstGeom>
+          <a:noFill/>
+          <a:ln/>
+        </p:spPr>
+        <p:txBody>
+          <a:bodyPr wrap="square" rtlCol="0" anchor="ctr"/>
+          <a:lstStyle/>
+          <a:p>
+            <a:pPr indent="0" marL="0">
+              <a:buNone/>
+            </a:pPr>
+            <a:r>
+              <a:rPr lang="en-US" sz="1200" dirty="0">
+                <a:solidFill>
+                  <a:srgbClr val="1A1A1A"/>
+                </a:solidFill>
+              </a:rPr>
+              <a:t>2.  Find the endpoint y-values.</a:t>
+            </a:r>
             <a:endParaRPr lang="en-US" sz="1200" dirty="0"/>
           </a:p>
         </p:txBody>
       </p:sp>
       <p:sp>
         <p:nvSpPr>
-          <p:cNvPr id="9" name="Text 7"/>
-          <p:cNvSpPr/>
-          <p:nvPr/>
-        </p:nvSpPr>
-        <p:spPr>
-          <a:xfrm>
-            <a:off x="384048" y="1847088"/>
-            <a:ext cx="4522988" cy="347472"/>
-          </a:xfrm>
-          <a:prstGeom prst="rect">
-            <a:avLst/>
-          </a:prstGeom>
-          <a:noFill/>
-          <a:ln/>
-        </p:spPr>
-        <p:txBody>
-          <a:bodyPr wrap="square" rtlCol="0" anchor="ctr"/>
-          <a:lstStyle/>
-          <a:p>
-            <a:pPr indent="0" marL="0">
-              <a:buNone/>
-            </a:pPr>
-            <a:r>
-              <a:rPr lang="en-US" sz="1100" dirty="0">
-                <a:solidFill>
-                  <a:srgbClr val="1A1A1A"/>
-                </a:solidFill>
-              </a:rPr>
-              <a:t>2.  Find the endpoint y-values.</a:t>
-            </a:r>
-            <a:endParaRPr lang="en-US" sz="1100" dirty="0"/>
-          </a:p>
-        </p:txBody>
-      </p:sp>
-      <p:sp>
-        <p:nvSpPr>
           <p:cNvPr id="10" name="Shape 8"/>
           <p:cNvSpPr/>
           <p:nvPr/>
         </p:nvSpPr>
         <p:spPr>
           <a:xfrm>
-            <a:off x="5158313" y="1847088"/>
-            <a:ext cx="3434121" cy="329184"/>
+            <a:off x="6879031" y="2231136"/>
+            <a:ext cx="4586326" cy="384048"/>
           </a:xfrm>
           <a:prstGeom prst="rect">
             <a:avLst/>
@@ -3481,24 +3584,24 @@
         </p:nvSpPr>
         <p:spPr>
           <a:xfrm>
-            <a:off x="5249753" y="1874520"/>
-            <a:ext cx="3251241" cy="274320"/>
-          </a:xfrm>
-          <a:prstGeom prst="rect">
-            <a:avLst/>
-          </a:prstGeom>
-          <a:noFill/>
-          <a:ln/>
-        </p:spPr>
-        <p:txBody>
-          <a:bodyPr wrap="square" rtlCol="0" anchor="ctr"/>
-          <a:lstStyle/>
-          <a:p>
-            <a:pPr indent="0" marL="0">
-              <a:buNone/>
-            </a:pPr>
-            <a:r>
-              <a:rPr lang="en-US" sz="1200" dirty="0">
+            <a:off x="7007047" y="2258568"/>
+            <a:ext cx="4330294" cy="329184"/>
+          </a:xfrm>
+          <a:prstGeom prst="rect">
+            <a:avLst/>
+          </a:prstGeom>
+          <a:noFill/>
+          <a:ln/>
+        </p:spPr>
+        <p:txBody>
+          <a:bodyPr wrap="square" rtlCol="0" anchor="ctr"/>
+          <a:lstStyle/>
+          <a:p>
+            <a:pPr indent="0" marL="0">
+              <a:buNone/>
+            </a:pPr>
+            <a:r>
+              <a:rPr lang="en-US" sz="1300" dirty="0">
                 <a:solidFill>
                   <a:srgbClr val="1A1A1A"/>
                 </a:solidFill>
@@ -3508,56 +3611,56 @@
               </a:rPr>
               <a:t>y₀=f(0)=0, y₁=f(2)=4</a:t>
             </a:r>
+            <a:endParaRPr lang="en-US" sz="1300" dirty="0"/>
+          </a:p>
+        </p:txBody>
+      </p:sp>
+      <p:sp>
+        <p:nvSpPr>
+          <p:cNvPr id="12" name="Text 10"/>
+          <p:cNvSpPr/>
+          <p:nvPr/>
+        </p:nvSpPr>
+        <p:spPr>
+          <a:xfrm>
+            <a:off x="502920" y="2706624"/>
+            <a:ext cx="6040526" cy="402336"/>
+          </a:xfrm>
+          <a:prstGeom prst="rect">
+            <a:avLst/>
+          </a:prstGeom>
+          <a:noFill/>
+          <a:ln/>
+        </p:spPr>
+        <p:txBody>
+          <a:bodyPr wrap="square" rtlCol="0" anchor="ctr"/>
+          <a:lstStyle/>
+          <a:p>
+            <a:pPr indent="0" marL="0">
+              <a:buNone/>
+            </a:pPr>
+            <a:r>
+              <a:rPr lang="en-US" sz="1200" dirty="0">
+                <a:solidFill>
+                  <a:srgbClr val="1A1A1A"/>
+                </a:solidFill>
+              </a:rPr>
+              <a:t>3.  Use the one-trapezoid rule.</a:t>
+            </a:r>
             <a:endParaRPr lang="en-US" sz="1200" dirty="0"/>
           </a:p>
         </p:txBody>
       </p:sp>
       <p:sp>
         <p:nvSpPr>
-          <p:cNvPr id="12" name="Text 10"/>
-          <p:cNvSpPr/>
-          <p:nvPr/>
-        </p:nvSpPr>
-        <p:spPr>
-          <a:xfrm>
-            <a:off x="384048" y="2249424"/>
-            <a:ext cx="4522988" cy="347472"/>
-          </a:xfrm>
-          <a:prstGeom prst="rect">
-            <a:avLst/>
-          </a:prstGeom>
-          <a:noFill/>
-          <a:ln/>
-        </p:spPr>
-        <p:txBody>
-          <a:bodyPr wrap="square" rtlCol="0" anchor="ctr"/>
-          <a:lstStyle/>
-          <a:p>
-            <a:pPr indent="0" marL="0">
-              <a:buNone/>
-            </a:pPr>
-            <a:r>
-              <a:rPr lang="en-US" sz="1100" dirty="0">
-                <a:solidFill>
-                  <a:srgbClr val="1A1A1A"/>
-                </a:solidFill>
-              </a:rPr>
-              <a:t>3.  Use the one-trapezoid rule.</a:t>
-            </a:r>
-            <a:endParaRPr lang="en-US" sz="1100" dirty="0"/>
-          </a:p>
-        </p:txBody>
-      </p:sp>
-      <p:sp>
-        <p:nvSpPr>
           <p:cNvPr id="13" name="Shape 11"/>
           <p:cNvSpPr/>
           <p:nvPr/>
         </p:nvSpPr>
         <p:spPr>
           <a:xfrm>
-            <a:off x="5158313" y="2249424"/>
-            <a:ext cx="3434121" cy="329184"/>
+            <a:off x="6879031" y="2706624"/>
+            <a:ext cx="4586326" cy="384048"/>
           </a:xfrm>
           <a:prstGeom prst="rect">
             <a:avLst/>
@@ -3576,24 +3679,24 @@
         </p:nvSpPr>
         <p:spPr>
           <a:xfrm>
-            <a:off x="5249753" y="2276856"/>
-            <a:ext cx="3251241" cy="274320"/>
-          </a:xfrm>
-          <a:prstGeom prst="rect">
-            <a:avLst/>
-          </a:prstGeom>
-          <a:noFill/>
-          <a:ln/>
-        </p:spPr>
-        <p:txBody>
-          <a:bodyPr wrap="square" rtlCol="0" anchor="ctr"/>
-          <a:lstStyle/>
-          <a:p>
-            <a:pPr indent="0" marL="0">
-              <a:buNone/>
-            </a:pPr>
-            <a:r>
-              <a:rPr lang="en-US" sz="1200" dirty="0">
+            <a:off x="7007047" y="2734056"/>
+            <a:ext cx="4330294" cy="329184"/>
+          </a:xfrm>
+          <a:prstGeom prst="rect">
+            <a:avLst/>
+          </a:prstGeom>
+          <a:noFill/>
+          <a:ln/>
+        </p:spPr>
+        <p:txBody>
+          <a:bodyPr wrap="square" rtlCol="0" anchor="ctr"/>
+          <a:lstStyle/>
+          <a:p>
+            <a:pPr indent="0" marL="0">
+              <a:buNone/>
+            </a:pPr>
+            <a:r>
+              <a:rPr lang="en-US" sz="1300" dirty="0">
                 <a:solidFill>
                   <a:srgbClr val="1A1A1A"/>
                 </a:solidFill>
@@ -3603,7 +3706,7 @@
               </a:rPr>
               <a:t>(2)/(2)(0+4)=4</a:t>
             </a:r>
-            <a:endParaRPr lang="en-US" sz="1200" dirty="0"/>
+            <a:endParaRPr lang="en-US" sz="1300" dirty="0"/>
           </a:p>
         </p:txBody>
       </p:sp>
@@ -3615,8 +3718,8 @@
         </p:nvSpPr>
         <p:spPr>
           <a:xfrm>
-            <a:off x="384048" y="4558284"/>
-            <a:ext cx="8375904" cy="402336"/>
+            <a:off x="502920" y="6144768"/>
+            <a:ext cx="11186160" cy="512064"/>
           </a:xfrm>
           <a:prstGeom prst="rect">
             <a:avLst/>
@@ -3635,24 +3738,24 @@
         </p:nvSpPr>
         <p:spPr>
           <a:xfrm>
-            <a:off x="530352" y="4576572"/>
-            <a:ext cx="8083296" cy="365760"/>
-          </a:xfrm>
-          <a:prstGeom prst="rect">
-            <a:avLst/>
-          </a:prstGeom>
-          <a:noFill/>
-          <a:ln/>
-        </p:spPr>
-        <p:txBody>
-          <a:bodyPr wrap="square" rtlCol="0" anchor="ctr"/>
-          <a:lstStyle/>
-          <a:p>
-            <a:pPr indent="0" marL="0">
-              <a:buNone/>
-            </a:pPr>
-            <a:r>
-              <a:rPr lang="en-US" sz="1300" b="1" dirty="0">
+            <a:off x="685800" y="6163056"/>
+            <a:ext cx="10820400" cy="475488"/>
+          </a:xfrm>
+          <a:prstGeom prst="rect">
+            <a:avLst/>
+          </a:prstGeom>
+          <a:noFill/>
+          <a:ln/>
+        </p:spPr>
+        <p:txBody>
+          <a:bodyPr wrap="square" rtlCol="0" anchor="ctr"/>
+          <a:lstStyle/>
+          <a:p>
+            <a:pPr indent="0" marL="0">
+              <a:buNone/>
+            </a:pPr>
+            <a:r>
+              <a:rPr lang="en-US" sz="1400" b="1" dirty="0">
                 <a:solidFill>
                   <a:srgbClr val="FFFFFF"/>
                 </a:solidFill>
@@ -3662,7 +3765,7 @@
               </a:rPr>
               <a:t>Answer:  4</a:t>
             </a:r>
-            <a:endParaRPr lang="en-US" sz="1300" dirty="0"/>
+            <a:endParaRPr lang="en-US" sz="1400" dirty="0"/>
           </a:p>
         </p:txBody>
       </p:sp>
@@ -3700,7 +3803,7 @@
         <p:spPr>
           <a:xfrm>
             <a:off x="0" y="0"/>
-            <a:ext cx="9144000" cy="658368"/>
+            <a:ext cx="12192000" cy="804672"/>
           </a:xfrm>
           <a:prstGeom prst="rect">
             <a:avLst/>
@@ -3719,31 +3822,31 @@
         </p:nvSpPr>
         <p:spPr>
           <a:xfrm>
-            <a:off x="384048" y="0"/>
-            <a:ext cx="8375904" cy="658368"/>
-          </a:xfrm>
-          <a:prstGeom prst="rect">
-            <a:avLst/>
-          </a:prstGeom>
-          <a:noFill/>
-          <a:ln/>
-        </p:spPr>
-        <p:txBody>
-          <a:bodyPr wrap="square" rtlCol="0" anchor="ctr"/>
-          <a:lstStyle/>
-          <a:p>
-            <a:pPr indent="0" marL="0">
-              <a:buNone/>
-            </a:pPr>
-            <a:r>
-              <a:rPr lang="en-US" sz="1800" b="1" dirty="0">
+            <a:off x="502920" y="0"/>
+            <a:ext cx="11186160" cy="804672"/>
+          </a:xfrm>
+          <a:prstGeom prst="rect">
+            <a:avLst/>
+          </a:prstGeom>
+          <a:noFill/>
+          <a:ln/>
+        </p:spPr>
+        <p:txBody>
+          <a:bodyPr wrap="square" rtlCol="0" anchor="ctr"/>
+          <a:lstStyle/>
+          <a:p>
+            <a:pPr indent="0" marL="0">
+              <a:buNone/>
+            </a:pPr>
+            <a:r>
+              <a:rPr lang="en-US" sz="2200" b="1" dirty="0">
                 <a:solidFill>
                   <a:srgbClr val="FFFFFF"/>
                 </a:solidFill>
               </a:rPr>
               <a:t>Worked Example 2: Two Trapezoids</a:t>
             </a:r>
-            <a:endParaRPr lang="en-US" sz="1800" dirty="0"/>
+            <a:endParaRPr lang="en-US" sz="2200" dirty="0"/>
           </a:p>
         </p:txBody>
       </p:sp>
@@ -3755,11 +3858,13 @@
         </p:nvSpPr>
         <p:spPr>
           <a:xfrm>
-            <a:off x="384048" y="841248"/>
-            <a:ext cx="8375904" cy="493776"/>
-          </a:xfrm>
-          <a:prstGeom prst="rect">
-            <a:avLst/>
+            <a:off x="502920" y="1005840"/>
+            <a:ext cx="11186160" cy="603504"/>
+          </a:xfrm>
+          <a:prstGeom prst="roundRect">
+            <a:avLst>
+              <a:gd name="adj" fmla="val 15152"/>
+            </a:avLst>
           </a:prstGeom>
           <a:solidFill>
             <a:srgbClr val="EBF4FF"/>
@@ -3775,24 +3880,24 @@
         </p:nvSpPr>
         <p:spPr>
           <a:xfrm>
-            <a:off x="512064" y="877824"/>
-            <a:ext cx="8119872" cy="420624"/>
-          </a:xfrm>
-          <a:prstGeom prst="rect">
-            <a:avLst/>
-          </a:prstGeom>
-          <a:noFill/>
-          <a:ln/>
-        </p:spPr>
-        <p:txBody>
-          <a:bodyPr wrap="square" rtlCol="0" anchor="ctr"/>
-          <a:lstStyle/>
-          <a:p>
-            <a:pPr indent="0" marL="0">
-              <a:buNone/>
-            </a:pPr>
-            <a:r>
-              <a:rPr lang="en-US" sz="1200" dirty="0">
+            <a:off x="667512" y="1060704"/>
+            <a:ext cx="10856976" cy="493776"/>
+          </a:xfrm>
+          <a:prstGeom prst="rect">
+            <a:avLst/>
+          </a:prstGeom>
+          <a:noFill/>
+          <a:ln/>
+        </p:spPr>
+        <p:txBody>
+          <a:bodyPr wrap="square" rtlCol="0" anchor="ctr"/>
+          <a:lstStyle/>
+          <a:p>
+            <a:pPr indent="0" marL="0">
+              <a:buNone/>
+            </a:pPr>
+            <a:r>
+              <a:rPr lang="en-US" sz="1300" dirty="0">
                 <a:solidFill>
                   <a:srgbClr val="1A1A1A"/>
                 </a:solidFill>
@@ -3800,7 +3905,43 @@
                 <a:ea typeface="Cambria Math" pitchFamily="34" charset="-122"/>
                 <a:cs typeface="Cambria Math" pitchFamily="34" charset="-120"/>
               </a:rPr>
-              <a:t>Use two subintervals to approximate ∫ x² dx.</a:t>
+              <a:t>Use two subintervals to approximate ∫ x² dx.</a:t>
+            </a:r>
+            <a:endParaRPr lang="en-US" sz="1300" dirty="0"/>
+          </a:p>
+        </p:txBody>
+      </p:sp>
+      <p:sp>
+        <p:nvSpPr>
+          <p:cNvPr id="6" name="Text 4"/>
+          <p:cNvSpPr/>
+          <p:nvPr/>
+        </p:nvSpPr>
+        <p:spPr>
+          <a:xfrm>
+            <a:off x="502920" y="1755648"/>
+            <a:ext cx="6040526" cy="402336"/>
+          </a:xfrm>
+          <a:prstGeom prst="rect">
+            <a:avLst/>
+          </a:prstGeom>
+          <a:noFill/>
+          <a:ln/>
+        </p:spPr>
+        <p:txBody>
+          <a:bodyPr wrap="square" rtlCol="0" anchor="ctr"/>
+          <a:lstStyle/>
+          <a:p>
+            <a:pPr indent="0" marL="0">
+              <a:buNone/>
+            </a:pPr>
+            <a:r>
+              <a:rPr lang="en-US" sz="1200" dirty="0">
+                <a:solidFill>
+                  <a:srgbClr val="1A1A1A"/>
+                </a:solidFill>
+              </a:rPr>
+              <a:t>1.  The width is one.</a:t>
             </a:r>
             <a:endParaRPr lang="en-US" sz="1200" dirty="0"/>
           </a:p>
@@ -3808,50 +3949,14 @@
       </p:sp>
       <p:sp>
         <p:nvSpPr>
-          <p:cNvPr id="6" name="Text 4"/>
-          <p:cNvSpPr/>
-          <p:nvPr/>
-        </p:nvSpPr>
-        <p:spPr>
-          <a:xfrm>
-            <a:off x="384048" y="1444752"/>
-            <a:ext cx="4522988" cy="347472"/>
-          </a:xfrm>
-          <a:prstGeom prst="rect">
-            <a:avLst/>
-          </a:prstGeom>
-          <a:noFill/>
-          <a:ln/>
-        </p:spPr>
-        <p:txBody>
-          <a:bodyPr wrap="square" rtlCol="0" anchor="ctr"/>
-          <a:lstStyle/>
-          <a:p>
-            <a:pPr indent="0" marL="0">
-              <a:buNone/>
-            </a:pPr>
-            <a:r>
-              <a:rPr lang="en-US" sz="1100" dirty="0">
-                <a:solidFill>
-                  <a:srgbClr val="1A1A1A"/>
-                </a:solidFill>
-              </a:rPr>
-              <a:t>1.  The width is one.</a:t>
-            </a:r>
-            <a:endParaRPr lang="en-US" sz="1100" dirty="0"/>
-          </a:p>
-        </p:txBody>
-      </p:sp>
-      <p:sp>
-        <p:nvSpPr>
           <p:cNvPr id="7" name="Shape 5"/>
           <p:cNvSpPr/>
           <p:nvPr/>
         </p:nvSpPr>
         <p:spPr>
           <a:xfrm>
-            <a:off x="5158313" y="1444752"/>
-            <a:ext cx="3434121" cy="329184"/>
+            <a:off x="6879031" y="1755648"/>
+            <a:ext cx="4586326" cy="384048"/>
           </a:xfrm>
           <a:prstGeom prst="rect">
             <a:avLst/>
@@ -3870,24 +3975,24 @@
         </p:nvSpPr>
         <p:spPr>
           <a:xfrm>
-            <a:off x="5249753" y="1472184"/>
-            <a:ext cx="3251241" cy="274320"/>
-          </a:xfrm>
-          <a:prstGeom prst="rect">
-            <a:avLst/>
-          </a:prstGeom>
-          <a:noFill/>
-          <a:ln/>
-        </p:spPr>
-        <p:txBody>
-          <a:bodyPr wrap="square" rtlCol="0" anchor="ctr"/>
-          <a:lstStyle/>
-          <a:p>
-            <a:pPr indent="0" marL="0">
-              <a:buNone/>
-            </a:pPr>
-            <a:r>
-              <a:rPr lang="en-US" sz="1200" dirty="0">
+            <a:off x="7007047" y="1783080"/>
+            <a:ext cx="4330294" cy="329184"/>
+          </a:xfrm>
+          <a:prstGeom prst="rect">
+            <a:avLst/>
+          </a:prstGeom>
+          <a:noFill/>
+          <a:ln/>
+        </p:spPr>
+        <p:txBody>
+          <a:bodyPr wrap="square" rtlCol="0" anchor="ctr"/>
+          <a:lstStyle/>
+          <a:p>
+            <a:pPr indent="0" marL="0">
+              <a:buNone/>
+            </a:pPr>
+            <a:r>
+              <a:rPr lang="en-US" sz="1300" dirty="0">
                 <a:solidFill>
                   <a:srgbClr val="1A1A1A"/>
                 </a:solidFill>
@@ -3897,56 +4002,56 @@
               </a:rPr>
               <a:t>h=(2-0)/(2)=1</a:t>
             </a:r>
+            <a:endParaRPr lang="en-US" sz="1300" dirty="0"/>
+          </a:p>
+        </p:txBody>
+      </p:sp>
+      <p:sp>
+        <p:nvSpPr>
+          <p:cNvPr id="9" name="Text 7"/>
+          <p:cNvSpPr/>
+          <p:nvPr/>
+        </p:nvSpPr>
+        <p:spPr>
+          <a:xfrm>
+            <a:off x="502920" y="2231136"/>
+            <a:ext cx="6040526" cy="402336"/>
+          </a:xfrm>
+          <a:prstGeom prst="rect">
+            <a:avLst/>
+          </a:prstGeom>
+          <a:noFill/>
+          <a:ln/>
+        </p:spPr>
+        <p:txBody>
+          <a:bodyPr wrap="square" rtlCol="0" anchor="ctr"/>
+          <a:lstStyle/>
+          <a:p>
+            <a:pPr indent="0" marL="0">
+              <a:buNone/>
+            </a:pPr>
+            <a:r>
+              <a:rPr lang="en-US" sz="1200" dirty="0">
+                <a:solidFill>
+                  <a:srgbClr val="1A1A1A"/>
+                </a:solidFill>
+              </a:rPr>
+              <a:t>2.  Use x-values 0, 1 and 2.</a:t>
+            </a:r>
             <a:endParaRPr lang="en-US" sz="1200" dirty="0"/>
           </a:p>
         </p:txBody>
       </p:sp>
       <p:sp>
         <p:nvSpPr>
-          <p:cNvPr id="9" name="Text 7"/>
-          <p:cNvSpPr/>
-          <p:nvPr/>
-        </p:nvSpPr>
-        <p:spPr>
-          <a:xfrm>
-            <a:off x="384048" y="1847088"/>
-            <a:ext cx="4522988" cy="347472"/>
-          </a:xfrm>
-          <a:prstGeom prst="rect">
-            <a:avLst/>
-          </a:prstGeom>
-          <a:noFill/>
-          <a:ln/>
-        </p:spPr>
-        <p:txBody>
-          <a:bodyPr wrap="square" rtlCol="0" anchor="ctr"/>
-          <a:lstStyle/>
-          <a:p>
-            <a:pPr indent="0" marL="0">
-              <a:buNone/>
-            </a:pPr>
-            <a:r>
-              <a:rPr lang="en-US" sz="1100" dirty="0">
-                <a:solidFill>
-                  <a:srgbClr val="1A1A1A"/>
-                </a:solidFill>
-              </a:rPr>
-              <a:t>2.  Use x-values 0, 1 and 2.</a:t>
-            </a:r>
-            <a:endParaRPr lang="en-US" sz="1100" dirty="0"/>
-          </a:p>
-        </p:txBody>
-      </p:sp>
-      <p:sp>
-        <p:nvSpPr>
           <p:cNvPr id="10" name="Shape 8"/>
           <p:cNvSpPr/>
           <p:nvPr/>
         </p:nvSpPr>
         <p:spPr>
           <a:xfrm>
-            <a:off x="5158313" y="1847088"/>
-            <a:ext cx="3434121" cy="329184"/>
+            <a:off x="6879031" y="2231136"/>
+            <a:ext cx="4586326" cy="384048"/>
           </a:xfrm>
           <a:prstGeom prst="rect">
             <a:avLst/>
@@ -3965,24 +4070,24 @@
         </p:nvSpPr>
         <p:spPr>
           <a:xfrm>
-            <a:off x="5249753" y="1874520"/>
-            <a:ext cx="3251241" cy="274320"/>
-          </a:xfrm>
-          <a:prstGeom prst="rect">
-            <a:avLst/>
-          </a:prstGeom>
-          <a:noFill/>
-          <a:ln/>
-        </p:spPr>
-        <p:txBody>
-          <a:bodyPr wrap="square" rtlCol="0" anchor="ctr"/>
-          <a:lstStyle/>
-          <a:p>
-            <a:pPr indent="0" marL="0">
-              <a:buNone/>
-            </a:pPr>
-            <a:r>
-              <a:rPr lang="en-US" sz="1200" dirty="0">
+            <a:off x="7007047" y="2258568"/>
+            <a:ext cx="4330294" cy="329184"/>
+          </a:xfrm>
+          <a:prstGeom prst="rect">
+            <a:avLst/>
+          </a:prstGeom>
+          <a:noFill/>
+          <a:ln/>
+        </p:spPr>
+        <p:txBody>
+          <a:bodyPr wrap="square" rtlCol="0" anchor="ctr"/>
+          <a:lstStyle/>
+          <a:p>
+            <a:pPr indent="0" marL="0">
+              <a:buNone/>
+            </a:pPr>
+            <a:r>
+              <a:rPr lang="en-US" sz="1300" dirty="0">
                 <a:solidFill>
                   <a:srgbClr val="1A1A1A"/>
                 </a:solidFill>
@@ -3992,56 +4097,56 @@
               </a:rPr>
               <a:t>y₀=0, y₁=1, y₂=4</a:t>
             </a:r>
+            <a:endParaRPr lang="en-US" sz="1300" dirty="0"/>
+          </a:p>
+        </p:txBody>
+      </p:sp>
+      <p:sp>
+        <p:nvSpPr>
+          <p:cNvPr id="12" name="Text 10"/>
+          <p:cNvSpPr/>
+          <p:nvPr/>
+        </p:nvSpPr>
+        <p:spPr>
+          <a:xfrm>
+            <a:off x="502920" y="2706624"/>
+            <a:ext cx="6040526" cy="402336"/>
+          </a:xfrm>
+          <a:prstGeom prst="rect">
+            <a:avLst/>
+          </a:prstGeom>
+          <a:noFill/>
+          <a:ln/>
+        </p:spPr>
+        <p:txBody>
+          <a:bodyPr wrap="square" rtlCol="0" anchor="ctr"/>
+          <a:lstStyle/>
+          <a:p>
+            <a:pPr indent="0" marL="0">
+              <a:buNone/>
+            </a:pPr>
+            <a:r>
+              <a:rPr lang="en-US" sz="1200" dirty="0">
+                <a:solidFill>
+                  <a:srgbClr val="1A1A1A"/>
+                </a:solidFill>
+              </a:rPr>
+              <a:t>3.  Double the interior value.</a:t>
+            </a:r>
             <a:endParaRPr lang="en-US" sz="1200" dirty="0"/>
           </a:p>
         </p:txBody>
       </p:sp>
       <p:sp>
         <p:nvSpPr>
-          <p:cNvPr id="12" name="Text 10"/>
-          <p:cNvSpPr/>
-          <p:nvPr/>
-        </p:nvSpPr>
-        <p:spPr>
-          <a:xfrm>
-            <a:off x="384048" y="2249424"/>
-            <a:ext cx="4522988" cy="347472"/>
-          </a:xfrm>
-          <a:prstGeom prst="rect">
-            <a:avLst/>
-          </a:prstGeom>
-          <a:noFill/>
-          <a:ln/>
-        </p:spPr>
-        <p:txBody>
-          <a:bodyPr wrap="square" rtlCol="0" anchor="ctr"/>
-          <a:lstStyle/>
-          <a:p>
-            <a:pPr indent="0" marL="0">
-              <a:buNone/>
-            </a:pPr>
-            <a:r>
-              <a:rPr lang="en-US" sz="1100" dirty="0">
-                <a:solidFill>
-                  <a:srgbClr val="1A1A1A"/>
-                </a:solidFill>
-              </a:rPr>
-              <a:t>3.  Double the interior value.</a:t>
-            </a:r>
-            <a:endParaRPr lang="en-US" sz="1100" dirty="0"/>
-          </a:p>
-        </p:txBody>
-      </p:sp>
-      <p:sp>
-        <p:nvSpPr>
           <p:cNvPr id="13" name="Shape 11"/>
           <p:cNvSpPr/>
           <p:nvPr/>
         </p:nvSpPr>
         <p:spPr>
           <a:xfrm>
-            <a:off x="5158313" y="2249424"/>
-            <a:ext cx="3434121" cy="329184"/>
+            <a:off x="6879031" y="2706624"/>
+            <a:ext cx="4586326" cy="384048"/>
           </a:xfrm>
           <a:prstGeom prst="rect">
             <a:avLst/>
@@ -4060,24 +4165,24 @@
         </p:nvSpPr>
         <p:spPr>
           <a:xfrm>
-            <a:off x="5249753" y="2276856"/>
-            <a:ext cx="3251241" cy="274320"/>
-          </a:xfrm>
-          <a:prstGeom prst="rect">
-            <a:avLst/>
-          </a:prstGeom>
-          <a:noFill/>
-          <a:ln/>
-        </p:spPr>
-        <p:txBody>
-          <a:bodyPr wrap="square" rtlCol="0" anchor="ctr"/>
-          <a:lstStyle/>
-          <a:p>
-            <a:pPr indent="0" marL="0">
-              <a:buNone/>
-            </a:pPr>
-            <a:r>
-              <a:rPr lang="en-US" sz="1200" dirty="0">
+            <a:off x="7007047" y="2734056"/>
+            <a:ext cx="4330294" cy="329184"/>
+          </a:xfrm>
+          <a:prstGeom prst="rect">
+            <a:avLst/>
+          </a:prstGeom>
+          <a:noFill/>
+          <a:ln/>
+        </p:spPr>
+        <p:txBody>
+          <a:bodyPr wrap="square" rtlCol="0" anchor="ctr"/>
+          <a:lstStyle/>
+          <a:p>
+            <a:pPr indent="0" marL="0">
+              <a:buNone/>
+            </a:pPr>
+            <a:r>
+              <a:rPr lang="en-US" sz="1300" dirty="0">
                 <a:solidFill>
                   <a:srgbClr val="1A1A1A"/>
                 </a:solidFill>
@@ -4087,7 +4192,7 @@
               </a:rPr>
               <a:t>1/2(0+2(1)+4)=3</a:t>
             </a:r>
-            <a:endParaRPr lang="en-US" sz="1200" dirty="0"/>
+            <a:endParaRPr lang="en-US" sz="1300" dirty="0"/>
           </a:p>
         </p:txBody>
       </p:sp>
@@ -4099,8 +4204,8 @@
         </p:nvSpPr>
         <p:spPr>
           <a:xfrm>
-            <a:off x="384048" y="4558284"/>
-            <a:ext cx="8375904" cy="402336"/>
+            <a:off x="502920" y="6144768"/>
+            <a:ext cx="11186160" cy="512064"/>
           </a:xfrm>
           <a:prstGeom prst="rect">
             <a:avLst/>
@@ -4119,24 +4224,24 @@
         </p:nvSpPr>
         <p:spPr>
           <a:xfrm>
-            <a:off x="530352" y="4576572"/>
-            <a:ext cx="8083296" cy="365760"/>
-          </a:xfrm>
-          <a:prstGeom prst="rect">
-            <a:avLst/>
-          </a:prstGeom>
-          <a:noFill/>
-          <a:ln/>
-        </p:spPr>
-        <p:txBody>
-          <a:bodyPr wrap="square" rtlCol="0" anchor="ctr"/>
-          <a:lstStyle/>
-          <a:p>
-            <a:pPr indent="0" marL="0">
-              <a:buNone/>
-            </a:pPr>
-            <a:r>
-              <a:rPr lang="en-US" sz="1300" b="1" dirty="0">
+            <a:off x="685800" y="6163056"/>
+            <a:ext cx="10820400" cy="475488"/>
+          </a:xfrm>
+          <a:prstGeom prst="rect">
+            <a:avLst/>
+          </a:prstGeom>
+          <a:noFill/>
+          <a:ln/>
+        </p:spPr>
+        <p:txBody>
+          <a:bodyPr wrap="square" rtlCol="0" anchor="ctr"/>
+          <a:lstStyle/>
+          <a:p>
+            <a:pPr indent="0" marL="0">
+              <a:buNone/>
+            </a:pPr>
+            <a:r>
+              <a:rPr lang="en-US" sz="1400" b="1" dirty="0">
                 <a:solidFill>
                   <a:srgbClr val="FFFFFF"/>
                 </a:solidFill>
@@ -4146,7 +4251,7 @@
               </a:rPr>
               <a:t>Answer:  3</a:t>
             </a:r>
-            <a:endParaRPr lang="en-US" sz="1300" dirty="0"/>
+            <a:endParaRPr lang="en-US" sz="1400" dirty="0"/>
           </a:p>
         </p:txBody>
       </p:sp>
@@ -4184,7 +4289,7 @@
         <p:spPr>
           <a:xfrm>
             <a:off x="0" y="0"/>
-            <a:ext cx="9144000" cy="658368"/>
+            <a:ext cx="12192000" cy="804672"/>
           </a:xfrm>
           <a:prstGeom prst="rect">
             <a:avLst/>
@@ -4203,31 +4308,31 @@
         </p:nvSpPr>
         <p:spPr>
           <a:xfrm>
-            <a:off x="384048" y="0"/>
-            <a:ext cx="8375904" cy="658368"/>
-          </a:xfrm>
-          <a:prstGeom prst="rect">
-            <a:avLst/>
-          </a:prstGeom>
-          <a:noFill/>
-          <a:ln/>
-        </p:spPr>
-        <p:txBody>
-          <a:bodyPr wrap="square" rtlCol="0" anchor="ctr"/>
-          <a:lstStyle/>
-          <a:p>
-            <a:pPr indent="0" marL="0">
-              <a:buNone/>
-            </a:pPr>
-            <a:r>
-              <a:rPr lang="en-US" sz="1800" b="1" dirty="0">
+            <a:off x="502920" y="0"/>
+            <a:ext cx="11186160" cy="804672"/>
+          </a:xfrm>
+          <a:prstGeom prst="rect">
+            <a:avLst/>
+          </a:prstGeom>
+          <a:noFill/>
+          <a:ln/>
+        </p:spPr>
+        <p:txBody>
+          <a:bodyPr wrap="square" rtlCol="0" anchor="ctr"/>
+          <a:lstStyle/>
+          <a:p>
+            <a:pPr indent="0" marL="0">
+              <a:buNone/>
+            </a:pPr>
+            <a:r>
+              <a:rPr lang="en-US" sz="2200" b="1" dirty="0">
                 <a:solidFill>
                   <a:srgbClr val="FFFFFF"/>
                 </a:solidFill>
               </a:rPr>
               <a:t>Worked Example 3: Table of Values</a:t>
             </a:r>
-            <a:endParaRPr lang="en-US" sz="1800" dirty="0"/>
+            <a:endParaRPr lang="en-US" sz="2200" dirty="0"/>
           </a:p>
         </p:txBody>
       </p:sp>
@@ -4239,11 +4344,13 @@
         </p:nvSpPr>
         <p:spPr>
           <a:xfrm>
-            <a:off x="384048" y="841248"/>
-            <a:ext cx="8375904" cy="658368"/>
-          </a:xfrm>
-          <a:prstGeom prst="rect">
-            <a:avLst/>
+            <a:off x="502920" y="1005840"/>
+            <a:ext cx="11186160" cy="804672"/>
+          </a:xfrm>
+          <a:prstGeom prst="roundRect">
+            <a:avLst>
+              <a:gd name="adj" fmla="val 11364"/>
+            </a:avLst>
           </a:prstGeom>
           <a:solidFill>
             <a:srgbClr val="EBF4FF"/>
@@ -4259,24 +4366,24 @@
         </p:nvSpPr>
         <p:spPr>
           <a:xfrm>
-            <a:off x="512064" y="877824"/>
-            <a:ext cx="8119872" cy="585216"/>
-          </a:xfrm>
-          <a:prstGeom prst="rect">
-            <a:avLst/>
-          </a:prstGeom>
-          <a:noFill/>
-          <a:ln/>
-        </p:spPr>
-        <p:txBody>
-          <a:bodyPr wrap="square" rtlCol="0" anchor="ctr"/>
-          <a:lstStyle/>
-          <a:p>
-            <a:pPr indent="0" marL="0">
-              <a:buNone/>
-            </a:pPr>
-            <a:r>
-              <a:rPr lang="en-US" sz="1200" dirty="0">
+            <a:off x="667512" y="1060704"/>
+            <a:ext cx="10856976" cy="694944"/>
+          </a:xfrm>
+          <a:prstGeom prst="rect">
+            <a:avLst/>
+          </a:prstGeom>
+          <a:noFill/>
+          <a:ln/>
+        </p:spPr>
+        <p:txBody>
+          <a:bodyPr wrap="square" rtlCol="0" anchor="ctr"/>
+          <a:lstStyle/>
+          <a:p>
+            <a:pPr indent="0" marL="0">
+              <a:buNone/>
+            </a:pPr>
+            <a:r>
+              <a:rPr lang="en-US" sz="1300" dirty="0">
                 <a:solidFill>
                   <a:srgbClr val="1A1A1A"/>
                 </a:solidFill>
@@ -4286,14 +4393,14 @@
               </a:rPr>
               <a:t>x 0 1 2 3</a:t>
             </a:r>
-            <a:endParaRPr lang="en-US" sz="1200" dirty="0"/>
-          </a:p>
-          <a:p>
-            <a:pPr indent="0" marL="0">
-              <a:buNone/>
-            </a:pPr>
-            <a:r>
-              <a:rPr lang="en-US" sz="1200" dirty="0">
+            <a:endParaRPr lang="en-US" sz="1300" dirty="0"/>
+          </a:p>
+          <a:p>
+            <a:pPr indent="0" marL="0">
+              <a:buNone/>
+            </a:pPr>
+            <a:r>
+              <a:rPr lang="en-US" sz="1300" dirty="0">
                 <a:solidFill>
                   <a:srgbClr val="1A1A1A"/>
                 </a:solidFill>
@@ -4303,56 +4410,56 @@
               </a:rPr>
               <a:t>y 2 5 6 8</a:t>
             </a:r>
+            <a:endParaRPr lang="en-US" sz="1300" dirty="0"/>
+          </a:p>
+        </p:txBody>
+      </p:sp>
+      <p:sp>
+        <p:nvSpPr>
+          <p:cNvPr id="6" name="Text 4"/>
+          <p:cNvSpPr/>
+          <p:nvPr/>
+        </p:nvSpPr>
+        <p:spPr>
+          <a:xfrm>
+            <a:off x="502920" y="1956816"/>
+            <a:ext cx="6040526" cy="402336"/>
+          </a:xfrm>
+          <a:prstGeom prst="rect">
+            <a:avLst/>
+          </a:prstGeom>
+          <a:noFill/>
+          <a:ln/>
+        </p:spPr>
+        <p:txBody>
+          <a:bodyPr wrap="square" rtlCol="0" anchor="ctr"/>
+          <a:lstStyle/>
+          <a:p>
+            <a:pPr indent="0" marL="0">
+              <a:buNone/>
+            </a:pPr>
+            <a:r>
+              <a:rPr lang="en-US" sz="1200" dirty="0">
+                <a:solidFill>
+                  <a:srgbClr val="1A1A1A"/>
+                </a:solidFill>
+              </a:rPr>
+              <a:t>1.  The x-values are one unit apart.</a:t>
+            </a:r>
             <a:endParaRPr lang="en-US" sz="1200" dirty="0"/>
           </a:p>
         </p:txBody>
       </p:sp>
       <p:sp>
         <p:nvSpPr>
-          <p:cNvPr id="6" name="Text 4"/>
-          <p:cNvSpPr/>
-          <p:nvPr/>
-        </p:nvSpPr>
-        <p:spPr>
-          <a:xfrm>
-            <a:off x="384048" y="1609344"/>
-            <a:ext cx="4522988" cy="347472"/>
-          </a:xfrm>
-          <a:prstGeom prst="rect">
-            <a:avLst/>
-          </a:prstGeom>
-          <a:noFill/>
-          <a:ln/>
-        </p:spPr>
-        <p:txBody>
-          <a:bodyPr wrap="square" rtlCol="0" anchor="ctr"/>
-          <a:lstStyle/>
-          <a:p>
-            <a:pPr indent="0" marL="0">
-              <a:buNone/>
-            </a:pPr>
-            <a:r>
-              <a:rPr lang="en-US" sz="1100" dirty="0">
-                <a:solidFill>
-                  <a:srgbClr val="1A1A1A"/>
-                </a:solidFill>
-              </a:rPr>
-              <a:t>1.  The x-values are one unit apart.</a:t>
-            </a:r>
-            <a:endParaRPr lang="en-US" sz="1100" dirty="0"/>
-          </a:p>
-        </p:txBody>
-      </p:sp>
-      <p:sp>
-        <p:nvSpPr>
           <p:cNvPr id="7" name="Shape 5"/>
           <p:cNvSpPr/>
           <p:nvPr/>
         </p:nvSpPr>
         <p:spPr>
           <a:xfrm>
-            <a:off x="5158313" y="1609344"/>
-            <a:ext cx="3434121" cy="329184"/>
+            <a:off x="6879031" y="1956816"/>
+            <a:ext cx="4586326" cy="384048"/>
           </a:xfrm>
           <a:prstGeom prst="rect">
             <a:avLst/>
@@ -4371,24 +4478,24 @@
         </p:nvSpPr>
         <p:spPr>
           <a:xfrm>
-            <a:off x="5249753" y="1636776"/>
-            <a:ext cx="3251241" cy="274320"/>
-          </a:xfrm>
-          <a:prstGeom prst="rect">
-            <a:avLst/>
-          </a:prstGeom>
-          <a:noFill/>
-          <a:ln/>
-        </p:spPr>
-        <p:txBody>
-          <a:bodyPr wrap="square" rtlCol="0" anchor="ctr"/>
-          <a:lstStyle/>
-          <a:p>
-            <a:pPr indent="0" marL="0">
-              <a:buNone/>
-            </a:pPr>
-            <a:r>
-              <a:rPr lang="en-US" sz="1200" dirty="0">
+            <a:off x="7007047" y="1984248"/>
+            <a:ext cx="4330294" cy="329184"/>
+          </a:xfrm>
+          <a:prstGeom prst="rect">
+            <a:avLst/>
+          </a:prstGeom>
+          <a:noFill/>
+          <a:ln/>
+        </p:spPr>
+        <p:txBody>
+          <a:bodyPr wrap="square" rtlCol="0" anchor="ctr"/>
+          <a:lstStyle/>
+          <a:p>
+            <a:pPr indent="0" marL="0">
+              <a:buNone/>
+            </a:pPr>
+            <a:r>
+              <a:rPr lang="en-US" sz="1300" dirty="0">
                 <a:solidFill>
                   <a:srgbClr val="1A1A1A"/>
                 </a:solidFill>
@@ -4398,56 +4505,56 @@
               </a:rPr>
               <a:t>h=1</a:t>
             </a:r>
+            <a:endParaRPr lang="en-US" sz="1300" dirty="0"/>
+          </a:p>
+        </p:txBody>
+      </p:sp>
+      <p:sp>
+        <p:nvSpPr>
+          <p:cNvPr id="9" name="Text 7"/>
+          <p:cNvSpPr/>
+          <p:nvPr/>
+        </p:nvSpPr>
+        <p:spPr>
+          <a:xfrm>
+            <a:off x="502920" y="2432304"/>
+            <a:ext cx="6040526" cy="402336"/>
+          </a:xfrm>
+          <a:prstGeom prst="rect">
+            <a:avLst/>
+          </a:prstGeom>
+          <a:noFill/>
+          <a:ln/>
+        </p:spPr>
+        <p:txBody>
+          <a:bodyPr wrap="square" rtlCol="0" anchor="ctr"/>
+          <a:lstStyle/>
+          <a:p>
+            <a:pPr indent="0" marL="0">
+              <a:buNone/>
+            </a:pPr>
+            <a:r>
+              <a:rPr lang="en-US" sz="1200" dirty="0">
+                <a:solidFill>
+                  <a:srgbClr val="1A1A1A"/>
+                </a:solidFill>
+              </a:rPr>
+              <a:t>2.  Use endpoints once and interior values twice.</a:t>
+            </a:r>
             <a:endParaRPr lang="en-US" sz="1200" dirty="0"/>
           </a:p>
         </p:txBody>
       </p:sp>
       <p:sp>
         <p:nvSpPr>
-          <p:cNvPr id="9" name="Text 7"/>
-          <p:cNvSpPr/>
-          <p:nvPr/>
-        </p:nvSpPr>
-        <p:spPr>
-          <a:xfrm>
-            <a:off x="384048" y="2011680"/>
-            <a:ext cx="4522988" cy="347472"/>
-          </a:xfrm>
-          <a:prstGeom prst="rect">
-            <a:avLst/>
-          </a:prstGeom>
-          <a:noFill/>
-          <a:ln/>
-        </p:spPr>
-        <p:txBody>
-          <a:bodyPr wrap="square" rtlCol="0" anchor="ctr"/>
-          <a:lstStyle/>
-          <a:p>
-            <a:pPr indent="0" marL="0">
-              <a:buNone/>
-            </a:pPr>
-            <a:r>
-              <a:rPr lang="en-US" sz="1100" dirty="0">
-                <a:solidFill>
-                  <a:srgbClr val="1A1A1A"/>
-                </a:solidFill>
-              </a:rPr>
-              <a:t>2.  Use endpoints once and interior values twice.</a:t>
-            </a:r>
-            <a:endParaRPr lang="en-US" sz="1100" dirty="0"/>
-          </a:p>
-        </p:txBody>
-      </p:sp>
-      <p:sp>
-        <p:nvSpPr>
           <p:cNvPr id="10" name="Shape 8"/>
           <p:cNvSpPr/>
           <p:nvPr/>
         </p:nvSpPr>
         <p:spPr>
           <a:xfrm>
-            <a:off x="5158313" y="2011680"/>
-            <a:ext cx="3434121" cy="329184"/>
+            <a:off x="6879031" y="2432304"/>
+            <a:ext cx="4586326" cy="384048"/>
           </a:xfrm>
           <a:prstGeom prst="rect">
             <a:avLst/>
@@ -4466,24 +4573,24 @@
         </p:nvSpPr>
         <p:spPr>
           <a:xfrm>
-            <a:off x="5249753" y="2039112"/>
-            <a:ext cx="3251241" cy="274320"/>
-          </a:xfrm>
-          <a:prstGeom prst="rect">
-            <a:avLst/>
-          </a:prstGeom>
-          <a:noFill/>
-          <a:ln/>
-        </p:spPr>
-        <p:txBody>
-          <a:bodyPr wrap="square" rtlCol="0" anchor="ctr"/>
-          <a:lstStyle/>
-          <a:p>
-            <a:pPr indent="0" marL="0">
-              <a:buNone/>
-            </a:pPr>
-            <a:r>
-              <a:rPr lang="en-US" sz="1200" dirty="0">
+            <a:off x="7007047" y="2459736"/>
+            <a:ext cx="4330294" cy="329184"/>
+          </a:xfrm>
+          <a:prstGeom prst="rect">
+            <a:avLst/>
+          </a:prstGeom>
+          <a:noFill/>
+          <a:ln/>
+        </p:spPr>
+        <p:txBody>
+          <a:bodyPr wrap="square" rtlCol="0" anchor="ctr"/>
+          <a:lstStyle/>
+          <a:p>
+            <a:pPr indent="0" marL="0">
+              <a:buNone/>
+            </a:pPr>
+            <a:r>
+              <a:rPr lang="en-US" sz="1300" dirty="0">
                 <a:solidFill>
                   <a:srgbClr val="1A1A1A"/>
                 </a:solidFill>
@@ -4493,56 +4600,56 @@
               </a:rPr>
               <a:t>1/2(2+2(5)+2(6)+8)</a:t>
             </a:r>
+            <a:endParaRPr lang="en-US" sz="1300" dirty="0"/>
+          </a:p>
+        </p:txBody>
+      </p:sp>
+      <p:sp>
+        <p:nvSpPr>
+          <p:cNvPr id="12" name="Text 10"/>
+          <p:cNvSpPr/>
+          <p:nvPr/>
+        </p:nvSpPr>
+        <p:spPr>
+          <a:xfrm>
+            <a:off x="502920" y="2907792"/>
+            <a:ext cx="6040526" cy="402336"/>
+          </a:xfrm>
+          <a:prstGeom prst="rect">
+            <a:avLst/>
+          </a:prstGeom>
+          <a:noFill/>
+          <a:ln/>
+        </p:spPr>
+        <p:txBody>
+          <a:bodyPr wrap="square" rtlCol="0" anchor="ctr"/>
+          <a:lstStyle/>
+          <a:p>
+            <a:pPr indent="0" marL="0">
+              <a:buNone/>
+            </a:pPr>
+            <a:r>
+              <a:rPr lang="en-US" sz="1200" dirty="0">
+                <a:solidFill>
+                  <a:srgbClr val="1A1A1A"/>
+                </a:solidFill>
+              </a:rPr>
+              <a:t>3.  Evaluate the approximation.</a:t>
+            </a:r>
             <a:endParaRPr lang="en-US" sz="1200" dirty="0"/>
           </a:p>
         </p:txBody>
       </p:sp>
       <p:sp>
         <p:nvSpPr>
-          <p:cNvPr id="12" name="Text 10"/>
-          <p:cNvSpPr/>
-          <p:nvPr/>
-        </p:nvSpPr>
-        <p:spPr>
-          <a:xfrm>
-            <a:off x="384048" y="2414016"/>
-            <a:ext cx="4522988" cy="347472"/>
-          </a:xfrm>
-          <a:prstGeom prst="rect">
-            <a:avLst/>
-          </a:prstGeom>
-          <a:noFill/>
-          <a:ln/>
-        </p:spPr>
-        <p:txBody>
-          <a:bodyPr wrap="square" rtlCol="0" anchor="ctr"/>
-          <a:lstStyle/>
-          <a:p>
-            <a:pPr indent="0" marL="0">
-              <a:buNone/>
-            </a:pPr>
-            <a:r>
-              <a:rPr lang="en-US" sz="1100" dirty="0">
-                <a:solidFill>
-                  <a:srgbClr val="1A1A1A"/>
-                </a:solidFill>
-              </a:rPr>
-              <a:t>3.  Evaluate the approximation.</a:t>
-            </a:r>
-            <a:endParaRPr lang="en-US" sz="1100" dirty="0"/>
-          </a:p>
-        </p:txBody>
-      </p:sp>
-      <p:sp>
-        <p:nvSpPr>
           <p:cNvPr id="13" name="Shape 11"/>
           <p:cNvSpPr/>
           <p:nvPr/>
         </p:nvSpPr>
         <p:spPr>
           <a:xfrm>
-            <a:off x="5158313" y="2414016"/>
-            <a:ext cx="3434121" cy="329184"/>
+            <a:off x="6879031" y="2907792"/>
+            <a:ext cx="4586326" cy="384048"/>
           </a:xfrm>
           <a:prstGeom prst="rect">
             <a:avLst/>
@@ -4561,24 +4668,24 @@
         </p:nvSpPr>
         <p:spPr>
           <a:xfrm>
-            <a:off x="5249753" y="2441448"/>
-            <a:ext cx="3251241" cy="274320"/>
-          </a:xfrm>
-          <a:prstGeom prst="rect">
-            <a:avLst/>
-          </a:prstGeom>
-          <a:noFill/>
-          <a:ln/>
-        </p:spPr>
-        <p:txBody>
-          <a:bodyPr wrap="square" rtlCol="0" anchor="ctr"/>
-          <a:lstStyle/>
-          <a:p>
-            <a:pPr indent="0" marL="0">
-              <a:buNone/>
-            </a:pPr>
-            <a:r>
-              <a:rPr lang="en-US" sz="1200" dirty="0">
+            <a:off x="7007047" y="2935224"/>
+            <a:ext cx="4330294" cy="329184"/>
+          </a:xfrm>
+          <a:prstGeom prst="rect">
+            <a:avLst/>
+          </a:prstGeom>
+          <a:noFill/>
+          <a:ln/>
+        </p:spPr>
+        <p:txBody>
+          <a:bodyPr wrap="square" rtlCol="0" anchor="ctr"/>
+          <a:lstStyle/>
+          <a:p>
+            <a:pPr indent="0" marL="0">
+              <a:buNone/>
+            </a:pPr>
+            <a:r>
+              <a:rPr lang="en-US" sz="1300" dirty="0">
                 <a:solidFill>
                   <a:srgbClr val="1A1A1A"/>
                 </a:solidFill>
@@ -4588,7 +4695,7 @@
               </a:rPr>
               <a:t>16</a:t>
             </a:r>
-            <a:endParaRPr lang="en-US" sz="1200" dirty="0"/>
+            <a:endParaRPr lang="en-US" sz="1300" dirty="0"/>
           </a:p>
         </p:txBody>
       </p:sp>
@@ -4600,8 +4707,8 @@
         </p:nvSpPr>
         <p:spPr>
           <a:xfrm>
-            <a:off x="384048" y="4558284"/>
-            <a:ext cx="8375904" cy="402336"/>
+            <a:off x="502920" y="6144768"/>
+            <a:ext cx="11186160" cy="512064"/>
           </a:xfrm>
           <a:prstGeom prst="rect">
             <a:avLst/>
@@ -4620,24 +4727,24 @@
         </p:nvSpPr>
         <p:spPr>
           <a:xfrm>
-            <a:off x="530352" y="4576572"/>
-            <a:ext cx="8083296" cy="365760"/>
-          </a:xfrm>
-          <a:prstGeom prst="rect">
-            <a:avLst/>
-          </a:prstGeom>
-          <a:noFill/>
-          <a:ln/>
-        </p:spPr>
-        <p:txBody>
-          <a:bodyPr wrap="square" rtlCol="0" anchor="ctr"/>
-          <a:lstStyle/>
-          <a:p>
-            <a:pPr indent="0" marL="0">
-              <a:buNone/>
-            </a:pPr>
-            <a:r>
-              <a:rPr lang="en-US" sz="1300" b="1" dirty="0">
+            <a:off x="685800" y="6163056"/>
+            <a:ext cx="10820400" cy="475488"/>
+          </a:xfrm>
+          <a:prstGeom prst="rect">
+            <a:avLst/>
+          </a:prstGeom>
+          <a:noFill/>
+          <a:ln/>
+        </p:spPr>
+        <p:txBody>
+          <a:bodyPr wrap="square" rtlCol="0" anchor="ctr"/>
+          <a:lstStyle/>
+          <a:p>
+            <a:pPr indent="0" marL="0">
+              <a:buNone/>
+            </a:pPr>
+            <a:r>
+              <a:rPr lang="en-US" sz="1400" b="1" dirty="0">
                 <a:solidFill>
                   <a:srgbClr val="FFFFFF"/>
                 </a:solidFill>
@@ -4647,7 +4754,7 @@
               </a:rPr>
               <a:t>Answer:  16</a:t>
             </a:r>
-            <a:endParaRPr lang="en-US" sz="1300" dirty="0"/>
+            <a:endParaRPr lang="en-US" sz="1400" dirty="0"/>
           </a:p>
         </p:txBody>
       </p:sp>
@@ -4685,7 +4792,7 @@
         <p:spPr>
           <a:xfrm>
             <a:off x="0" y="0"/>
-            <a:ext cx="9144000" cy="658368"/>
+            <a:ext cx="12192000" cy="804672"/>
           </a:xfrm>
           <a:prstGeom prst="rect">
             <a:avLst/>
@@ -4704,31 +4811,31 @@
         </p:nvSpPr>
         <p:spPr>
           <a:xfrm>
-            <a:off x="384048" y="0"/>
-            <a:ext cx="8375904" cy="658368"/>
-          </a:xfrm>
-          <a:prstGeom prst="rect">
-            <a:avLst/>
-          </a:prstGeom>
-          <a:noFill/>
-          <a:ln/>
-        </p:spPr>
-        <p:txBody>
-          <a:bodyPr wrap="square" rtlCol="0" anchor="ctr"/>
-          <a:lstStyle/>
-          <a:p>
-            <a:pPr indent="0" marL="0">
-              <a:buNone/>
-            </a:pPr>
-            <a:r>
-              <a:rPr lang="en-US" sz="1800" b="1" dirty="0">
+            <a:off x="502920" y="0"/>
+            <a:ext cx="11186160" cy="804672"/>
+          </a:xfrm>
+          <a:prstGeom prst="rect">
+            <a:avLst/>
+          </a:prstGeom>
+          <a:noFill/>
+          <a:ln/>
+        </p:spPr>
+        <p:txBody>
+          <a:bodyPr wrap="square" rtlCol="0" anchor="ctr"/>
+          <a:lstStyle/>
+          <a:p>
+            <a:pPr indent="0" marL="0">
+              <a:buNone/>
+            </a:pPr>
+            <a:r>
+              <a:rPr lang="en-US" sz="2200" b="1" dirty="0">
                 <a:solidFill>
                   <a:srgbClr val="FFFFFF"/>
                 </a:solidFill>
               </a:rPr>
               <a:t>Worked Example 4: Concavity Interpretation</a:t>
             </a:r>
-            <a:endParaRPr lang="en-US" sz="1800" dirty="0"/>
+            <a:endParaRPr lang="en-US" sz="2200" dirty="0"/>
           </a:p>
         </p:txBody>
       </p:sp>
@@ -4740,11 +4847,13 @@
         </p:nvSpPr>
         <p:spPr>
           <a:xfrm>
-            <a:off x="384048" y="841248"/>
-            <a:ext cx="8375904" cy="493776"/>
-          </a:xfrm>
-          <a:prstGeom prst="rect">
-            <a:avLst/>
+            <a:off x="502920" y="1005840"/>
+            <a:ext cx="11186160" cy="603504"/>
+          </a:xfrm>
+          <a:prstGeom prst="roundRect">
+            <a:avLst>
+              <a:gd name="adj" fmla="val 15152"/>
+            </a:avLst>
           </a:prstGeom>
           <a:solidFill>
             <a:srgbClr val="EBF4FF"/>
@@ -4760,24 +4869,24 @@
         </p:nvSpPr>
         <p:spPr>
           <a:xfrm>
-            <a:off x="512064" y="877824"/>
-            <a:ext cx="8119872" cy="420624"/>
-          </a:xfrm>
-          <a:prstGeom prst="rect">
-            <a:avLst/>
-          </a:prstGeom>
-          <a:noFill/>
-          <a:ln/>
-        </p:spPr>
-        <p:txBody>
-          <a:bodyPr wrap="square" rtlCol="0" anchor="ctr"/>
-          <a:lstStyle/>
-          <a:p>
-            <a:pPr indent="0" marL="0">
-              <a:buNone/>
-            </a:pPr>
-            <a:r>
-              <a:rPr lang="en-US" sz="1200" dirty="0">
+            <a:off x="667512" y="1060704"/>
+            <a:ext cx="10856976" cy="493776"/>
+          </a:xfrm>
+          <a:prstGeom prst="rect">
+            <a:avLst/>
+          </a:prstGeom>
+          <a:noFill/>
+          <a:ln/>
+        </p:spPr>
+        <p:txBody>
+          <a:bodyPr wrap="square" rtlCol="0" anchor="ctr"/>
+          <a:lstStyle/>
+          <a:p>
+            <a:pPr indent="0" marL="0">
+              <a:buNone/>
+            </a:pPr>
+            <a:r>
+              <a:rPr lang="en-US" sz="1300" dirty="0">
                 <a:solidFill>
                   <a:srgbClr val="1A1A1A"/>
                 </a:solidFill>
@@ -4787,56 +4896,56 @@
               </a:rPr>
               <a:t>f(x)=x² on 0≤ xle2</a:t>
             </a:r>
+            <a:endParaRPr lang="en-US" sz="1300" dirty="0"/>
+          </a:p>
+        </p:txBody>
+      </p:sp>
+      <p:sp>
+        <p:nvSpPr>
+          <p:cNvPr id="6" name="Text 4"/>
+          <p:cNvSpPr/>
+          <p:nvPr/>
+        </p:nvSpPr>
+        <p:spPr>
+          <a:xfrm>
+            <a:off x="502920" y="1755648"/>
+            <a:ext cx="6040526" cy="402336"/>
+          </a:xfrm>
+          <a:prstGeom prst="rect">
+            <a:avLst/>
+          </a:prstGeom>
+          <a:noFill/>
+          <a:ln/>
+        </p:spPr>
+        <p:txBody>
+          <a:bodyPr wrap="square" rtlCol="0" anchor="ctr"/>
+          <a:lstStyle/>
+          <a:p>
+            <a:pPr indent="0" marL="0">
+              <a:buNone/>
+            </a:pPr>
+            <a:r>
+              <a:rPr lang="en-US" sz="1200" dirty="0">
+                <a:solidFill>
+                  <a:srgbClr val="1A1A1A"/>
+                </a:solidFill>
+              </a:rPr>
+              <a:t>1.  The graph is concave up.</a:t>
+            </a:r>
             <a:endParaRPr lang="en-US" sz="1200" dirty="0"/>
           </a:p>
         </p:txBody>
       </p:sp>
       <p:sp>
         <p:nvSpPr>
-          <p:cNvPr id="6" name="Text 4"/>
-          <p:cNvSpPr/>
-          <p:nvPr/>
-        </p:nvSpPr>
-        <p:spPr>
-          <a:xfrm>
-            <a:off x="384048" y="1444752"/>
-            <a:ext cx="4522988" cy="347472"/>
-          </a:xfrm>
-          <a:prstGeom prst="rect">
-            <a:avLst/>
-          </a:prstGeom>
-          <a:noFill/>
-          <a:ln/>
-        </p:spPr>
-        <p:txBody>
-          <a:bodyPr wrap="square" rtlCol="0" anchor="ctr"/>
-          <a:lstStyle/>
-          <a:p>
-            <a:pPr indent="0" marL="0">
-              <a:buNone/>
-            </a:pPr>
-            <a:r>
-              <a:rPr lang="en-US" sz="1100" dirty="0">
-                <a:solidFill>
-                  <a:srgbClr val="1A1A1A"/>
-                </a:solidFill>
-              </a:rPr>
-              <a:t>1.  The graph is concave up.</a:t>
-            </a:r>
-            <a:endParaRPr lang="en-US" sz="1100" dirty="0"/>
-          </a:p>
-        </p:txBody>
-      </p:sp>
-      <p:sp>
-        <p:nvSpPr>
           <p:cNvPr id="7" name="Shape 5"/>
           <p:cNvSpPr/>
           <p:nvPr/>
         </p:nvSpPr>
         <p:spPr>
           <a:xfrm>
-            <a:off x="5158313" y="1444752"/>
-            <a:ext cx="3434121" cy="329184"/>
+            <a:off x="6879031" y="1755648"/>
+            <a:ext cx="4586326" cy="384048"/>
           </a:xfrm>
           <a:prstGeom prst="rect">
             <a:avLst/>
@@ -4855,24 +4964,24 @@
         </p:nvSpPr>
         <p:spPr>
           <a:xfrm>
-            <a:off x="5249753" y="1472184"/>
-            <a:ext cx="3251241" cy="274320"/>
-          </a:xfrm>
-          <a:prstGeom prst="rect">
-            <a:avLst/>
-          </a:prstGeom>
-          <a:noFill/>
-          <a:ln/>
-        </p:spPr>
-        <p:txBody>
-          <a:bodyPr wrap="square" rtlCol="0" anchor="ctr"/>
-          <a:lstStyle/>
-          <a:p>
-            <a:pPr indent="0" marL="0">
-              <a:buNone/>
-            </a:pPr>
-            <a:r>
-              <a:rPr lang="en-US" sz="1200" dirty="0">
+            <a:off x="7007047" y="1783080"/>
+            <a:ext cx="4330294" cy="329184"/>
+          </a:xfrm>
+          <a:prstGeom prst="rect">
+            <a:avLst/>
+          </a:prstGeom>
+          <a:noFill/>
+          <a:ln/>
+        </p:spPr>
+        <p:txBody>
+          <a:bodyPr wrap="square" rtlCol="0" anchor="ctr"/>
+          <a:lstStyle/>
+          <a:p>
+            <a:pPr indent="0" marL="0">
+              <a:buNone/>
+            </a:pPr>
+            <a:r>
+              <a:rPr lang="en-US" sz="1300" dirty="0">
                 <a:solidFill>
                   <a:srgbClr val="1A1A1A"/>
                 </a:solidFill>
@@ -4882,79 +4991,79 @@
               </a:rPr>
               <a:t>f''(x)=2&gt;0</a:t>
             </a:r>
+            <a:endParaRPr lang="en-US" sz="1300" dirty="0"/>
+          </a:p>
+        </p:txBody>
+      </p:sp>
+      <p:sp>
+        <p:nvSpPr>
+          <p:cNvPr id="9" name="Text 7"/>
+          <p:cNvSpPr/>
+          <p:nvPr/>
+        </p:nvSpPr>
+        <p:spPr>
+          <a:xfrm>
+            <a:off x="502920" y="2231136"/>
+            <a:ext cx="6040526" cy="402336"/>
+          </a:xfrm>
+          <a:prstGeom prst="rect">
+            <a:avLst/>
+          </a:prstGeom>
+          <a:noFill/>
+          <a:ln/>
+        </p:spPr>
+        <p:txBody>
+          <a:bodyPr wrap="square" rtlCol="0" anchor="ctr"/>
+          <a:lstStyle/>
+          <a:p>
+            <a:pPr indent="0" marL="0">
+              <a:buNone/>
+            </a:pPr>
+            <a:r>
+              <a:rPr lang="en-US" sz="1200" dirty="0">
+                <a:solidFill>
+                  <a:srgbClr val="1A1A1A"/>
+                </a:solidFill>
+              </a:rPr>
+              <a:t>2.  Straight chords lie above a concave-up curve.</a:t>
+            </a:r>
             <a:endParaRPr lang="en-US" sz="1200" dirty="0"/>
           </a:p>
         </p:txBody>
       </p:sp>
       <p:sp>
         <p:nvSpPr>
-          <p:cNvPr id="9" name="Text 7"/>
-          <p:cNvSpPr/>
-          <p:nvPr/>
-        </p:nvSpPr>
-        <p:spPr>
-          <a:xfrm>
-            <a:off x="384048" y="1847088"/>
-            <a:ext cx="4522988" cy="347472"/>
-          </a:xfrm>
-          <a:prstGeom prst="rect">
-            <a:avLst/>
-          </a:prstGeom>
-          <a:noFill/>
-          <a:ln/>
-        </p:spPr>
-        <p:txBody>
-          <a:bodyPr wrap="square" rtlCol="0" anchor="ctr"/>
-          <a:lstStyle/>
-          <a:p>
-            <a:pPr indent="0" marL="0">
-              <a:buNone/>
-            </a:pPr>
-            <a:r>
-              <a:rPr lang="en-US" sz="1100" dirty="0">
+          <p:cNvPr id="10" name="Text 8"/>
+          <p:cNvSpPr/>
+          <p:nvPr/>
+        </p:nvSpPr>
+        <p:spPr>
+          <a:xfrm>
+            <a:off x="502920" y="2706624"/>
+            <a:ext cx="6040526" cy="402336"/>
+          </a:xfrm>
+          <a:prstGeom prst="rect">
+            <a:avLst/>
+          </a:prstGeom>
+          <a:noFill/>
+          <a:ln/>
+        </p:spPr>
+        <p:txBody>
+          <a:bodyPr wrap="square" rtlCol="0" anchor="ctr"/>
+          <a:lstStyle/>
+          <a:p>
+            <a:pPr indent="0" marL="0">
+              <a:buNone/>
+            </a:pPr>
+            <a:r>
+              <a:rPr lang="en-US" sz="1200" dirty="0">
                 <a:solidFill>
                   <a:srgbClr val="1A1A1A"/>
                 </a:solidFill>
               </a:rPr>
-              <a:t>2.  Straight chords lie above a concave-up curve.</a:t>
-            </a:r>
-            <a:endParaRPr lang="en-US" sz="1100" dirty="0"/>
-          </a:p>
-        </p:txBody>
-      </p:sp>
-      <p:sp>
-        <p:nvSpPr>
-          <p:cNvPr id="10" name="Text 8"/>
-          <p:cNvSpPr/>
-          <p:nvPr/>
-        </p:nvSpPr>
-        <p:spPr>
-          <a:xfrm>
-            <a:off x="384048" y="2249424"/>
-            <a:ext cx="4522988" cy="347472"/>
-          </a:xfrm>
-          <a:prstGeom prst="rect">
-            <a:avLst/>
-          </a:prstGeom>
-          <a:noFill/>
-          <a:ln/>
-        </p:spPr>
-        <p:txBody>
-          <a:bodyPr wrap="square" rtlCol="0" anchor="ctr"/>
-          <a:lstStyle/>
-          <a:p>
-            <a:pPr indent="0" marL="0">
-              <a:buNone/>
-            </a:pPr>
-            <a:r>
-              <a:rPr lang="en-US" sz="1100" dirty="0">
-                <a:solidFill>
-                  <a:srgbClr val="1A1A1A"/>
-                </a:solidFill>
-              </a:rPr>
               <a:t>3.  So the trapezoidal approximation overestimates the integral.</a:t>
             </a:r>
-            <a:endParaRPr lang="en-US" sz="1100" dirty="0"/>
+            <a:endParaRPr lang="en-US" sz="1200" dirty="0"/>
           </a:p>
         </p:txBody>
       </p:sp>
@@ -4966,8 +5075,8 @@
         </p:nvSpPr>
         <p:spPr>
           <a:xfrm>
-            <a:off x="384048" y="4558284"/>
-            <a:ext cx="8375904" cy="402336"/>
+            <a:off x="502920" y="6144768"/>
+            <a:ext cx="11186160" cy="512064"/>
           </a:xfrm>
           <a:prstGeom prst="rect">
             <a:avLst/>
@@ -4986,24 +5095,24 @@
         </p:nvSpPr>
         <p:spPr>
           <a:xfrm>
-            <a:off x="530352" y="4576572"/>
-            <a:ext cx="8083296" cy="365760"/>
-          </a:xfrm>
-          <a:prstGeom prst="rect">
-            <a:avLst/>
-          </a:prstGeom>
-          <a:noFill/>
-          <a:ln/>
-        </p:spPr>
-        <p:txBody>
-          <a:bodyPr wrap="square" rtlCol="0" anchor="ctr"/>
-          <a:lstStyle/>
-          <a:p>
-            <a:pPr indent="0" marL="0">
-              <a:buNone/>
-            </a:pPr>
-            <a:r>
-              <a:rPr lang="en-US" sz="1300" b="1" dirty="0">
+            <a:off x="685800" y="6163056"/>
+            <a:ext cx="10820400" cy="475488"/>
+          </a:xfrm>
+          <a:prstGeom prst="rect">
+            <a:avLst/>
+          </a:prstGeom>
+          <a:noFill/>
+          <a:ln/>
+        </p:spPr>
+        <p:txBody>
+          <a:bodyPr wrap="square" rtlCol="0" anchor="ctr"/>
+          <a:lstStyle/>
+          <a:p>
+            <a:pPr indent="0" marL="0">
+              <a:buNone/>
+            </a:pPr>
+            <a:r>
+              <a:rPr lang="en-US" sz="1400" b="1" dirty="0">
                 <a:solidFill>
                   <a:srgbClr val="FFFFFF"/>
                 </a:solidFill>
@@ -5013,7 +5122,7 @@
               </a:rPr>
               <a:t>Answer:  overestimate</a:t>
             </a:r>
-            <a:endParaRPr lang="en-US" sz="1300" dirty="0"/>
+            <a:endParaRPr lang="en-US" sz="1400" dirty="0"/>
           </a:p>
         </p:txBody>
       </p:sp>
@@ -5051,7 +5160,7 @@
         <p:spPr>
           <a:xfrm>
             <a:off x="0" y="0"/>
-            <a:ext cx="9144000" cy="658368"/>
+            <a:ext cx="12192000" cy="804672"/>
           </a:xfrm>
           <a:prstGeom prst="rect">
             <a:avLst/>
@@ -5070,31 +5179,31 @@
         </p:nvSpPr>
         <p:spPr>
           <a:xfrm>
-            <a:off x="384048" y="0"/>
-            <a:ext cx="8375904" cy="658368"/>
-          </a:xfrm>
-          <a:prstGeom prst="rect">
-            <a:avLst/>
-          </a:prstGeom>
-          <a:noFill/>
-          <a:ln/>
-        </p:spPr>
-        <p:txBody>
-          <a:bodyPr wrap="square" rtlCol="0" anchor="ctr"/>
-          <a:lstStyle/>
-          <a:p>
-            <a:pPr indent="0" marL="0">
-              <a:buNone/>
-            </a:pPr>
-            <a:r>
-              <a:rPr lang="en-US" sz="1800" b="1" dirty="0">
+            <a:off x="502920" y="0"/>
+            <a:ext cx="11186160" cy="804672"/>
+          </a:xfrm>
+          <a:prstGeom prst="rect">
+            <a:avLst/>
+          </a:prstGeom>
+          <a:noFill/>
+          <a:ln/>
+        </p:spPr>
+        <p:txBody>
+          <a:bodyPr wrap="square" rtlCol="0" anchor="ctr"/>
+          <a:lstStyle/>
+          <a:p>
+            <a:pPr indent="0" marL="0">
+              <a:buNone/>
+            </a:pPr>
+            <a:r>
+              <a:rPr lang="en-US" sz="2200" b="1" dirty="0">
                 <a:solidFill>
                   <a:srgbClr val="FFFFFF"/>
                 </a:solidFill>
               </a:rPr>
               <a:t>Common Mistakes (1 of 2)</a:t>
             </a:r>
-            <a:endParaRPr lang="en-US" sz="1800" dirty="0"/>
+            <a:endParaRPr lang="en-US" sz="2200" dirty="0"/>
           </a:p>
         </p:txBody>
       </p:sp>
@@ -5106,11 +5215,13 @@
         </p:nvSpPr>
         <p:spPr>
           <a:xfrm>
-            <a:off x="384048" y="841248"/>
-            <a:ext cx="3936675" cy="1959102"/>
-          </a:xfrm>
-          <a:prstGeom prst="rect">
-            <a:avLst/>
+            <a:off x="502920" y="1005840"/>
+            <a:ext cx="5257495" cy="2688336"/>
+          </a:xfrm>
+          <a:prstGeom prst="roundRect">
+            <a:avLst>
+              <a:gd name="adj" fmla="val 3401"/>
+            </a:avLst>
           </a:prstGeom>
           <a:solidFill>
             <a:srgbClr val="FEF2F2"/>
@@ -5126,11 +5237,13 @@
         </p:nvSpPr>
         <p:spPr>
           <a:xfrm>
-            <a:off x="4572000" y="841248"/>
-            <a:ext cx="3936675" cy="1959102"/>
-          </a:xfrm>
-          <a:prstGeom prst="rect">
-            <a:avLst/>
+            <a:off x="6096000" y="1005840"/>
+            <a:ext cx="5257495" cy="2688336"/>
+          </a:xfrm>
+          <a:prstGeom prst="roundRect">
+            <a:avLst>
+              <a:gd name="adj" fmla="val 3401"/>
+            </a:avLst>
           </a:prstGeom>
           <a:solidFill>
             <a:srgbClr val="F0FDF4"/>
@@ -5146,31 +5259,31 @@
         </p:nvSpPr>
         <p:spPr>
           <a:xfrm>
-            <a:off x="475488" y="905256"/>
-            <a:ext cx="3753795" cy="1831086"/>
-          </a:xfrm>
-          <a:prstGeom prst="rect">
-            <a:avLst/>
-          </a:prstGeom>
-          <a:noFill/>
-          <a:ln/>
-        </p:spPr>
-        <p:txBody>
-          <a:bodyPr wrap="square" rtlCol="0" anchor="ctr"/>
-          <a:lstStyle/>
-          <a:p>
-            <a:pPr indent="0" marL="0">
-              <a:buNone/>
-            </a:pPr>
-            <a:r>
-              <a:rPr lang="en-US" sz="1100" dirty="0">
+            <a:off x="649224" y="1115568"/>
+            <a:ext cx="4964887" cy="2468880"/>
+          </a:xfrm>
+          <a:prstGeom prst="rect">
+            <a:avLst/>
+          </a:prstGeom>
+          <a:noFill/>
+          <a:ln/>
+        </p:spPr>
+        <p:txBody>
+          <a:bodyPr wrap="square" rtlCol="0" anchor="ctr"/>
+          <a:lstStyle/>
+          <a:p>
+            <a:pPr indent="0" marL="0">
+              <a:buNone/>
+            </a:pPr>
+            <a:r>
+              <a:rPr lang="en-US" sz="1300" dirty="0">
                 <a:solidFill>
                   <a:srgbClr val="991B1B"/>
                 </a:solidFill>
               </a:rPr>
               <a:t>✗  Using n as the width.</a:t>
             </a:r>
-            <a:endParaRPr lang="en-US" sz="1100" dirty="0"/>
+            <a:endParaRPr lang="en-US" sz="1300" dirty="0"/>
           </a:p>
         </p:txBody>
       </p:sp>
@@ -5182,31 +5295,31 @@
         </p:nvSpPr>
         <p:spPr>
           <a:xfrm>
-            <a:off x="4663440" y="905256"/>
-            <a:ext cx="3753795" cy="1831086"/>
-          </a:xfrm>
-          <a:prstGeom prst="rect">
-            <a:avLst/>
-          </a:prstGeom>
-          <a:noFill/>
-          <a:ln/>
-        </p:spPr>
-        <p:txBody>
-          <a:bodyPr wrap="square" rtlCol="0" anchor="ctr"/>
-          <a:lstStyle/>
-          <a:p>
-            <a:pPr indent="0" marL="0">
-              <a:buNone/>
-            </a:pPr>
-            <a:r>
-              <a:rPr lang="en-US" sz="1100" dirty="0">
+            <a:off x="6242304" y="1115568"/>
+            <a:ext cx="4964887" cy="2468880"/>
+          </a:xfrm>
+          <a:prstGeom prst="rect">
+            <a:avLst/>
+          </a:prstGeom>
+          <a:noFill/>
+          <a:ln/>
+        </p:spPr>
+        <p:txBody>
+          <a:bodyPr wrap="square" rtlCol="0" anchor="ctr"/>
+          <a:lstStyle/>
+          <a:p>
+            <a:pPr indent="0" marL="0">
+              <a:buNone/>
+            </a:pPr>
+            <a:r>
+              <a:rPr lang="en-US" sz="1300" dirty="0">
                 <a:solidFill>
                   <a:srgbClr val="166534"/>
                 </a:solidFill>
               </a:rPr>
               <a:t>✓  The width is h=(b-a)/n, not the number of subintervals.</a:t>
             </a:r>
-            <a:endParaRPr lang="en-US" sz="1100" dirty="0"/>
+            <a:endParaRPr lang="en-US" sz="1300" dirty="0"/>
           </a:p>
         </p:txBody>
       </p:sp>
@@ -5218,11 +5331,13 @@
         </p:nvSpPr>
         <p:spPr>
           <a:xfrm>
-            <a:off x="384048" y="2864358"/>
-            <a:ext cx="3936675" cy="1959102"/>
-          </a:xfrm>
-          <a:prstGeom prst="rect">
-            <a:avLst/>
+            <a:off x="502920" y="3785616"/>
+            <a:ext cx="5257495" cy="2688336"/>
+          </a:xfrm>
+          <a:prstGeom prst="roundRect">
+            <a:avLst>
+              <a:gd name="adj" fmla="val 3401"/>
+            </a:avLst>
           </a:prstGeom>
           <a:solidFill>
             <a:srgbClr val="FEF2F2"/>
@@ -5238,11 +5353,13 @@
         </p:nvSpPr>
         <p:spPr>
           <a:xfrm>
-            <a:off x="4572000" y="2864358"/>
-            <a:ext cx="3936675" cy="1959102"/>
-          </a:xfrm>
-          <a:prstGeom prst="rect">
-            <a:avLst/>
+            <a:off x="6096000" y="3785616"/>
+            <a:ext cx="5257495" cy="2688336"/>
+          </a:xfrm>
+          <a:prstGeom prst="roundRect">
+            <a:avLst>
+              <a:gd name="adj" fmla="val 3401"/>
+            </a:avLst>
           </a:prstGeom>
           <a:solidFill>
             <a:srgbClr val="F0FDF4"/>
@@ -5258,31 +5375,31 @@
         </p:nvSpPr>
         <p:spPr>
           <a:xfrm>
-            <a:off x="475488" y="2928366"/>
-            <a:ext cx="3753795" cy="1831086"/>
-          </a:xfrm>
-          <a:prstGeom prst="rect">
-            <a:avLst/>
-          </a:prstGeom>
-          <a:noFill/>
-          <a:ln/>
-        </p:spPr>
-        <p:txBody>
-          <a:bodyPr wrap="square" rtlCol="0" anchor="ctr"/>
-          <a:lstStyle/>
-          <a:p>
-            <a:pPr indent="0" marL="0">
-              <a:buNone/>
-            </a:pPr>
-            <a:r>
-              <a:rPr lang="en-US" sz="1100" dirty="0">
+            <a:off x="649224" y="3895344"/>
+            <a:ext cx="4964887" cy="2468880"/>
+          </a:xfrm>
+          <a:prstGeom prst="rect">
+            <a:avLst/>
+          </a:prstGeom>
+          <a:noFill/>
+          <a:ln/>
+        </p:spPr>
+        <p:txBody>
+          <a:bodyPr wrap="square" rtlCol="0" anchor="ctr"/>
+          <a:lstStyle/>
+          <a:p>
+            <a:pPr indent="0" marL="0">
+              <a:buNone/>
+            </a:pPr>
+            <a:r>
+              <a:rPr lang="en-US" sz="1300" dirty="0">
                 <a:solidFill>
                   <a:srgbClr val="991B1B"/>
                 </a:solidFill>
               </a:rPr>
               <a:t>✗  Forgetting to double interior values.</a:t>
             </a:r>
-            <a:endParaRPr lang="en-US" sz="1100" dirty="0"/>
+            <a:endParaRPr lang="en-US" sz="1300" dirty="0"/>
           </a:p>
         </p:txBody>
       </p:sp>
@@ -5294,31 +5411,31 @@
         </p:nvSpPr>
         <p:spPr>
           <a:xfrm>
-            <a:off x="4663440" y="2928366"/>
-            <a:ext cx="3753795" cy="1831086"/>
-          </a:xfrm>
-          <a:prstGeom prst="rect">
-            <a:avLst/>
-          </a:prstGeom>
-          <a:noFill/>
-          <a:ln/>
-        </p:spPr>
-        <p:txBody>
-          <a:bodyPr wrap="square" rtlCol="0" anchor="ctr"/>
-          <a:lstStyle/>
-          <a:p>
-            <a:pPr indent="0" marL="0">
-              <a:buNone/>
-            </a:pPr>
-            <a:r>
-              <a:rPr lang="en-US" sz="1100" dirty="0">
+            <a:off x="6242304" y="3895344"/>
+            <a:ext cx="4964887" cy="2468880"/>
+          </a:xfrm>
+          <a:prstGeom prst="rect">
+            <a:avLst/>
+          </a:prstGeom>
+          <a:noFill/>
+          <a:ln/>
+        </p:spPr>
+        <p:txBody>
+          <a:bodyPr wrap="square" rtlCol="0" anchor="ctr"/>
+          <a:lstStyle/>
+          <a:p>
+            <a:pPr indent="0" marL="0">
+              <a:buNone/>
+            </a:pPr>
+            <a:r>
+              <a:rPr lang="en-US" sz="1300" dirty="0">
                 <a:solidFill>
                   <a:srgbClr val="166534"/>
                 </a:solidFill>
               </a:rPr>
               <a:t>✓  Every interior y-value has coefficient 2 in the composite trapezoidal rule.</a:t>
             </a:r>
-            <a:endParaRPr lang="en-US" sz="1100" dirty="0"/>
+            <a:endParaRPr lang="en-US" sz="1300" dirty="0"/>
           </a:p>
         </p:txBody>
       </p:sp>
@@ -5356,7 +5473,7 @@
         <p:spPr>
           <a:xfrm>
             <a:off x="0" y="0"/>
-            <a:ext cx="9144000" cy="658368"/>
+            <a:ext cx="12192000" cy="804672"/>
           </a:xfrm>
           <a:prstGeom prst="rect">
             <a:avLst/>
@@ -5375,31 +5492,31 @@
         </p:nvSpPr>
         <p:spPr>
           <a:xfrm>
-            <a:off x="384048" y="0"/>
-            <a:ext cx="8375904" cy="658368"/>
-          </a:xfrm>
-          <a:prstGeom prst="rect">
-            <a:avLst/>
-          </a:prstGeom>
-          <a:noFill/>
-          <a:ln/>
-        </p:spPr>
-        <p:txBody>
-          <a:bodyPr wrap="square" rtlCol="0" anchor="ctr"/>
-          <a:lstStyle/>
-          <a:p>
-            <a:pPr indent="0" marL="0">
-              <a:buNone/>
-            </a:pPr>
-            <a:r>
-              <a:rPr lang="en-US" sz="1800" b="1" dirty="0">
+            <a:off x="502920" y="0"/>
+            <a:ext cx="11186160" cy="804672"/>
+          </a:xfrm>
+          <a:prstGeom prst="rect">
+            <a:avLst/>
+          </a:prstGeom>
+          <a:noFill/>
+          <a:ln/>
+        </p:spPr>
+        <p:txBody>
+          <a:bodyPr wrap="square" rtlCol="0" anchor="ctr"/>
+          <a:lstStyle/>
+          <a:p>
+            <a:pPr indent="0" marL="0">
+              <a:buNone/>
+            </a:pPr>
+            <a:r>
+              <a:rPr lang="en-US" sz="2200" b="1" dirty="0">
                 <a:solidFill>
                   <a:srgbClr val="FFFFFF"/>
                 </a:solidFill>
               </a:rPr>
               <a:t>Common Mistakes (2 of 2)</a:t>
             </a:r>
-            <a:endParaRPr lang="en-US" sz="1800" dirty="0"/>
+            <a:endParaRPr lang="en-US" sz="2200" dirty="0"/>
           </a:p>
         </p:txBody>
       </p:sp>
@@ -5411,11 +5528,13 @@
         </p:nvSpPr>
         <p:spPr>
           <a:xfrm>
-            <a:off x="384048" y="841248"/>
-            <a:ext cx="3936675" cy="1959102"/>
-          </a:xfrm>
-          <a:prstGeom prst="rect">
-            <a:avLst/>
+            <a:off x="502920" y="1005840"/>
+            <a:ext cx="5257495" cy="2688336"/>
+          </a:xfrm>
+          <a:prstGeom prst="roundRect">
+            <a:avLst>
+              <a:gd name="adj" fmla="val 3401"/>
+            </a:avLst>
           </a:prstGeom>
           <a:solidFill>
             <a:srgbClr val="FEF2F2"/>
@@ -5431,11 +5550,13 @@
         </p:nvSpPr>
         <p:spPr>
           <a:xfrm>
-            <a:off x="4572000" y="841248"/>
-            <a:ext cx="3936675" cy="1959102"/>
-          </a:xfrm>
-          <a:prstGeom prst="rect">
-            <a:avLst/>
+            <a:off x="6096000" y="1005840"/>
+            <a:ext cx="5257495" cy="2688336"/>
+          </a:xfrm>
+          <a:prstGeom prst="roundRect">
+            <a:avLst>
+              <a:gd name="adj" fmla="val 3401"/>
+            </a:avLst>
           </a:prstGeom>
           <a:solidFill>
             <a:srgbClr val="F0FDF4"/>
@@ -5451,31 +5572,31 @@
         </p:nvSpPr>
         <p:spPr>
           <a:xfrm>
-            <a:off x="475488" y="905256"/>
-            <a:ext cx="3753795" cy="1831086"/>
-          </a:xfrm>
-          <a:prstGeom prst="rect">
-            <a:avLst/>
-          </a:prstGeom>
-          <a:noFill/>
-          <a:ln/>
-        </p:spPr>
-        <p:txBody>
-          <a:bodyPr wrap="square" rtlCol="0" anchor="ctr"/>
-          <a:lstStyle/>
-          <a:p>
-            <a:pPr indent="0" marL="0">
-              <a:buNone/>
-            </a:pPr>
-            <a:r>
-              <a:rPr lang="en-US" sz="1100" dirty="0">
+            <a:off x="649224" y="1115568"/>
+            <a:ext cx="4964887" cy="2468880"/>
+          </a:xfrm>
+          <a:prstGeom prst="rect">
+            <a:avLst/>
+          </a:prstGeom>
+          <a:noFill/>
+          <a:ln/>
+        </p:spPr>
+        <p:txBody>
+          <a:bodyPr wrap="square" rtlCol="0" anchor="ctr"/>
+          <a:lstStyle/>
+          <a:p>
+            <a:pPr indent="0" marL="0">
+              <a:buNone/>
+            </a:pPr>
+            <a:r>
+              <a:rPr lang="en-US" sz="1300" dirty="0">
                 <a:solidFill>
                   <a:srgbClr val="991B1B"/>
                 </a:solidFill>
               </a:rPr>
               <a:t>✗  Forgetting the factor h/2.</a:t>
             </a:r>
-            <a:endParaRPr lang="en-US" sz="1100" dirty="0"/>
+            <a:endParaRPr lang="en-US" sz="1300" dirty="0"/>
           </a:p>
         </p:txBody>
       </p:sp>
@@ -5487,31 +5608,31 @@
         </p:nvSpPr>
         <p:spPr>
           <a:xfrm>
-            <a:off x="4663440" y="905256"/>
-            <a:ext cx="3753795" cy="1831086"/>
-          </a:xfrm>
-          <a:prstGeom prst="rect">
-            <a:avLst/>
-          </a:prstGeom>
-          <a:noFill/>
-          <a:ln/>
-        </p:spPr>
-        <p:txBody>
-          <a:bodyPr wrap="square" rtlCol="0" anchor="ctr"/>
-          <a:lstStyle/>
-          <a:p>
-            <a:pPr indent="0" marL="0">
-              <a:buNone/>
-            </a:pPr>
-            <a:r>
-              <a:rPr lang="en-US" sz="1100" dirty="0">
+            <a:off x="6242304" y="1115568"/>
+            <a:ext cx="4964887" cy="2468880"/>
+          </a:xfrm>
+          <a:prstGeom prst="rect">
+            <a:avLst/>
+          </a:prstGeom>
+          <a:noFill/>
+          <a:ln/>
+        </p:spPr>
+        <p:txBody>
+          <a:bodyPr wrap="square" rtlCol="0" anchor="ctr"/>
+          <a:lstStyle/>
+          <a:p>
+            <a:pPr indent="0" marL="0">
+              <a:buNone/>
+            </a:pPr>
+            <a:r>
+              <a:rPr lang="en-US" sz="1300" dirty="0">
                 <a:solidFill>
                   <a:srgbClr val="166534"/>
                 </a:solidFill>
               </a:rPr>
               <a:t>✓  The final bracket must be multiplied by h/2.</a:t>
             </a:r>
-            <a:endParaRPr lang="en-US" sz="1100" dirty="0"/>
+            <a:endParaRPr lang="en-US" sz="1300" dirty="0"/>
           </a:p>
         </p:txBody>
       </p:sp>
@@ -5523,11 +5644,13 @@
         </p:nvSpPr>
         <p:spPr>
           <a:xfrm>
-            <a:off x="384048" y="2864358"/>
-            <a:ext cx="3936675" cy="1959102"/>
-          </a:xfrm>
-          <a:prstGeom prst="rect">
-            <a:avLst/>
+            <a:off x="502920" y="3785616"/>
+            <a:ext cx="5257495" cy="2688336"/>
+          </a:xfrm>
+          <a:prstGeom prst="roundRect">
+            <a:avLst>
+              <a:gd name="adj" fmla="val 3401"/>
+            </a:avLst>
           </a:prstGeom>
           <a:solidFill>
             <a:srgbClr val="FEF2F2"/>
@@ -5543,11 +5666,13 @@
         </p:nvSpPr>
         <p:spPr>
           <a:xfrm>
-            <a:off x="4572000" y="2864358"/>
-            <a:ext cx="3936675" cy="1959102"/>
-          </a:xfrm>
-          <a:prstGeom prst="rect">
-            <a:avLst/>
+            <a:off x="6096000" y="3785616"/>
+            <a:ext cx="5257495" cy="2688336"/>
+          </a:xfrm>
+          <a:prstGeom prst="roundRect">
+            <a:avLst>
+              <a:gd name="adj" fmla="val 3401"/>
+            </a:avLst>
           </a:prstGeom>
           <a:solidFill>
             <a:srgbClr val="F0FDF4"/>
@@ -5563,31 +5688,31 @@
         </p:nvSpPr>
         <p:spPr>
           <a:xfrm>
-            <a:off x="475488" y="2928366"/>
-            <a:ext cx="3753795" cy="1831086"/>
-          </a:xfrm>
-          <a:prstGeom prst="rect">
-            <a:avLst/>
-          </a:prstGeom>
-          <a:noFill/>
-          <a:ln/>
-        </p:spPr>
-        <p:txBody>
-          <a:bodyPr wrap="square" rtlCol="0" anchor="ctr"/>
-          <a:lstStyle/>
-          <a:p>
-            <a:pPr indent="0" marL="0">
-              <a:buNone/>
-            </a:pPr>
-            <a:r>
-              <a:rPr lang="en-US" sz="1100" dirty="0">
+            <a:off x="649224" y="3895344"/>
+            <a:ext cx="4964887" cy="2468880"/>
+          </a:xfrm>
+          <a:prstGeom prst="rect">
+            <a:avLst/>
+          </a:prstGeom>
+          <a:noFill/>
+          <a:ln/>
+        </p:spPr>
+        <p:txBody>
+          <a:bodyPr wrap="square" rtlCol="0" anchor="ctr"/>
+          <a:lstStyle/>
+          <a:p>
+            <a:pPr indent="0" marL="0">
+              <a:buNone/>
+            </a:pPr>
+            <a:r>
+              <a:rPr lang="en-US" sz="1300" dirty="0">
                 <a:solidFill>
                   <a:srgbClr val="991B1B"/>
                 </a:solidFill>
               </a:rPr>
               <a:t>✗  Assuming the rule is exact for all curves.</a:t>
             </a:r>
-            <a:endParaRPr lang="en-US" sz="1100" dirty="0"/>
+            <a:endParaRPr lang="en-US" sz="1300" dirty="0"/>
           </a:p>
         </p:txBody>
       </p:sp>
@@ -5599,31 +5724,31 @@
         </p:nvSpPr>
         <p:spPr>
           <a:xfrm>
-            <a:off x="4663440" y="2928366"/>
-            <a:ext cx="3753795" cy="1831086"/>
-          </a:xfrm>
-          <a:prstGeom prst="rect">
-            <a:avLst/>
-          </a:prstGeom>
-          <a:noFill/>
-          <a:ln/>
-        </p:spPr>
-        <p:txBody>
-          <a:bodyPr wrap="square" rtlCol="0" anchor="ctr"/>
-          <a:lstStyle/>
-          <a:p>
-            <a:pPr indent="0" marL="0">
-              <a:buNone/>
-            </a:pPr>
-            <a:r>
-              <a:rPr lang="en-US" sz="1100" dirty="0">
+            <a:off x="6242304" y="3895344"/>
+            <a:ext cx="4964887" cy="2468880"/>
+          </a:xfrm>
+          <a:prstGeom prst="rect">
+            <a:avLst/>
+          </a:prstGeom>
+          <a:noFill/>
+          <a:ln/>
+        </p:spPr>
+        <p:txBody>
+          <a:bodyPr wrap="square" rtlCol="0" anchor="ctr"/>
+          <a:lstStyle/>
+          <a:p>
+            <a:pPr indent="0" marL="0">
+              <a:buNone/>
+            </a:pPr>
+            <a:r>
+              <a:rPr lang="en-US" sz="1300" dirty="0">
                 <a:solidFill>
                   <a:srgbClr val="166534"/>
                 </a:solidFill>
               </a:rPr>
               <a:t>✓  It is exact for straight-line data, but curved graphs are usually only approximated.</a:t>
             </a:r>
-            <a:endParaRPr lang="en-US" sz="1100" dirty="0"/>
+            <a:endParaRPr lang="en-US" sz="1300" dirty="0"/>
           </a:p>
         </p:txBody>
       </p:sp>

</xml_diff>